<commit_message>
slides(fix): fix 3 G0 blockers in gemini-enterprise-agents ch01 [KOEA-1538]
- Strip KnowledgeCheck/Callout JSX blocks from slide body extraction
- Add "what's next" and "hands-on exercise" to SKIP_SECTIONS
- Prefer ###-subheadings and list items as bullets; fall back to prose
  first-sentences only when < 3 structured bullets found — eliminates
  wall-of-text narrative paragraphs from content slides
- Slide count: 11 → 9 (removed Hands-on exercise + What's next slides)

Co-Authored-By: Claude Sonnet 4.6 <noreply@anthropic.com>
</commit_message>
<xml_diff>
--- a/vault/courses/gemini-enterprise-agents/ch01-slides.pptx
+++ b/vault/courses/gemini-enterprise-agents/ch01-slides.pptx
@@ -14,8 +14,6 @@
     <p:sldId id="262" r:id="rId13"/>
     <p:sldId id="263" r:id="rId14"/>
     <p:sldId id="264" r:id="rId15"/>
-    <p:sldId id="265" r:id="rId16"/>
-    <p:sldId id="266" r:id="rId17"/>
   </p:sldIdLst>
   <p:sldSz cx="12191695" cy="6858000" type="screen4x3"/>
   <p:notesSz cx="6858000" cy="9144000"/>
@@ -3284,450 +3282,6 @@
 </p:sld>
 </file>
 
-<file path=ppt/slides/slide10.xml><?xml version="1.0" encoding="utf-8"?>
-<p:sld xmlns:a="http://schemas.openxmlformats.org/drawingml/2006/main" xmlns:p="http://schemas.openxmlformats.org/presentationml/2006/main" xmlns:r="http://schemas.openxmlformats.org/officeDocument/2006/relationships">
-  <p:cSld>
-    <p:bg>
-      <p:bgPr>
-        <a:solidFill>
-          <a:srgbClr val="18181B"/>
-        </a:solidFill>
-        <a:effectLst/>
-      </p:bgPr>
-    </p:bg>
-    <p:spTree>
-      <p:nvGrpSpPr>
-        <p:cNvPr id="1" name=""/>
-        <p:cNvGrpSpPr/>
-        <p:nvPr/>
-      </p:nvGrpSpPr>
-      <p:grpSpPr/>
-      <p:sp>
-        <p:nvSpPr>
-          <p:cNvPr id="2" name="TextBox 1"/>
-          <p:cNvSpPr txBox="1"/>
-          <p:nvPr/>
-        </p:nvSpPr>
-        <p:spPr>
-          <a:xfrm>
-            <a:off x="731520" y="411480"/>
-            <a:ext cx="10698480" cy="1005840"/>
-          </a:xfrm>
-          <a:prstGeom prst="rect">
-            <a:avLst/>
-          </a:prstGeom>
-          <a:noFill/>
-        </p:spPr>
-        <p:txBody>
-          <a:bodyPr wrap="square">
-            <a:spAutoFit/>
-          </a:bodyPr>
-          <a:lstStyle/>
-          <a:p>
-            <a:pPr algn="l"/>
-            <a:r>
-              <a:rPr sz="2600" b="1">
-                <a:solidFill>
-                  <a:srgbClr val="FFFFFF"/>
-                </a:solidFill>
-              </a:rPr>
-              <a:t>What's next</a:t>
-            </a:r>
-          </a:p>
-        </p:txBody>
-      </p:sp>
-      <p:sp>
-        <p:nvSpPr>
-          <p:cNvPr id="3" name="Rectangle 2"/>
-          <p:cNvSpPr/>
-          <p:nvPr/>
-        </p:nvSpPr>
-        <p:spPr>
-          <a:xfrm>
-            <a:off x="731520" y="1417320"/>
-            <a:ext cx="10698480" cy="36576"/>
-          </a:xfrm>
-          <a:prstGeom prst="rect">
-            <a:avLst/>
-          </a:prstGeom>
-          <a:solidFill>
-            <a:srgbClr val="A1A1AA"/>
-          </a:solidFill>
-          <a:ln>
-            <a:noFill/>
-          </a:ln>
-        </p:spPr>
-        <p:style>
-          <a:lnRef idx="1">
-            <a:schemeClr val="accent1"/>
-          </a:lnRef>
-          <a:fillRef idx="3">
-            <a:schemeClr val="accent1"/>
-          </a:fillRef>
-          <a:effectRef idx="2">
-            <a:schemeClr val="accent1"/>
-          </a:effectRef>
-          <a:fontRef idx="minor">
-            <a:schemeClr val="lt1"/>
-          </a:fontRef>
-        </p:style>
-        <p:txBody>
-          <a:bodyPr rtlCol="0" anchor="ctr"/>
-          <a:lstStyle/>
-          <a:p>
-            <a:pPr algn="ctr"/>
-          </a:p>
-        </p:txBody>
-      </p:sp>
-      <p:sp>
-        <p:nvSpPr>
-          <p:cNvPr id="4" name="TextBox 3"/>
-          <p:cNvSpPr txBox="1"/>
-          <p:nvPr/>
-        </p:nvSpPr>
-        <p:spPr>
-          <a:xfrm>
-            <a:off x="731520" y="1600200"/>
-            <a:ext cx="10698480" cy="960120"/>
-          </a:xfrm>
-          <a:prstGeom prst="rect">
-            <a:avLst/>
-          </a:prstGeom>
-          <a:noFill/>
-        </p:spPr>
-        <p:txBody>
-          <a:bodyPr wrap="square">
-            <a:spAutoFit/>
-          </a:bodyPr>
-          <a:lstStyle/>
-          <a:p>
-            <a:pPr algn="l"/>
-            <a:r>
-              <a:rPr sz="1600" b="0">
-                <a:solidFill>
-                  <a:srgbClr val="FFFFFF"/>
-                </a:solidFill>
-              </a:rPr>
-              <a:t>  Chapter 2 gets hands-on: you will install ADK, define a Python function as a tool, wire it into an Agent, and add sessio</a:t>
-            </a:r>
-          </a:p>
-        </p:txBody>
-      </p:sp>
-      <p:sp>
-        <p:nvSpPr>
-          <p:cNvPr id="5" name="TextBox 4"/>
-          <p:cNvSpPr txBox="1"/>
-          <p:nvPr/>
-        </p:nvSpPr>
-        <p:spPr>
-          <a:xfrm>
-            <a:off x="731520" y="2651760"/>
-            <a:ext cx="10698480" cy="960120"/>
-          </a:xfrm>
-          <a:prstGeom prst="rect">
-            <a:avLst/>
-          </a:prstGeom>
-          <a:noFill/>
-        </p:spPr>
-        <p:txBody>
-          <a:bodyPr wrap="square">
-            <a:spAutoFit/>
-          </a:bodyPr>
-          <a:lstStyle/>
-          <a:p>
-            <a:pPr algn="l"/>
-            <a:r>
-              <a:rPr sz="1600" b="0">
-                <a:solidFill>
-                  <a:srgbClr val="FFFFFF"/>
-                </a:solidFill>
-              </a:rPr>
-              <a:t>  See gemini-enterprise-agent-platform-hands-on-tour/02-hello-world-agent-tool-state-persistence to continue.</a:t>
-            </a:r>
-          </a:p>
-        </p:txBody>
-      </p:sp>
-      <p:sp>
-        <p:nvSpPr>
-          <p:cNvPr id="6" name="TextBox 5"/>
-          <p:cNvSpPr txBox="1"/>
-          <p:nvPr/>
-        </p:nvSpPr>
-        <p:spPr>
-          <a:xfrm>
-            <a:off x="731520" y="6263640"/>
-            <a:ext cx="10698480" cy="365760"/>
-          </a:xfrm>
-          <a:prstGeom prst="rect">
-            <a:avLst/>
-          </a:prstGeom>
-          <a:noFill/>
-        </p:spPr>
-        <p:txBody>
-          <a:bodyPr wrap="square">
-            <a:spAutoFit/>
-          </a:bodyPr>
-          <a:lstStyle/>
-          <a:p>
-            <a:pPr algn="l"/>
-            <a:r>
-              <a:rPr sz="1000" b="0">
-                <a:solidFill>
-                  <a:srgbClr val="A1A1AA"/>
-                </a:solidFill>
-              </a:rPr>
-              <a:t>academy.kspl.tech | Koenig AI Academy</a:t>
-            </a:r>
-          </a:p>
-        </p:txBody>
-      </p:sp>
-    </p:spTree>
-  </p:cSld>
-  <p:clrMapOvr>
-    <a:masterClrMapping/>
-  </p:clrMapOvr>
-</p:sld>
-</file>
-
-<file path=ppt/slides/slide11.xml><?xml version="1.0" encoding="utf-8"?>
-<p:sld xmlns:a="http://schemas.openxmlformats.org/drawingml/2006/main" xmlns:p="http://schemas.openxmlformats.org/presentationml/2006/main" xmlns:r="http://schemas.openxmlformats.org/officeDocument/2006/relationships">
-  <p:cSld>
-    <p:bg>
-      <p:bgPr>
-        <a:solidFill>
-          <a:srgbClr val="18181B"/>
-        </a:solidFill>
-        <a:effectLst/>
-      </p:bgPr>
-    </p:bg>
-    <p:spTree>
-      <p:nvGrpSpPr>
-        <p:cNvPr id="1" name=""/>
-        <p:cNvGrpSpPr/>
-        <p:nvPr/>
-      </p:nvGrpSpPr>
-      <p:grpSpPr/>
-      <p:sp>
-        <p:nvSpPr>
-          <p:cNvPr id="2" name="TextBox 1"/>
-          <p:cNvSpPr txBox="1"/>
-          <p:nvPr/>
-        </p:nvSpPr>
-        <p:spPr>
-          <a:xfrm>
-            <a:off x="914400" y="1645920"/>
-            <a:ext cx="10332720" cy="822960"/>
-          </a:xfrm>
-          <a:prstGeom prst="rect">
-            <a:avLst/>
-          </a:prstGeom>
-          <a:noFill/>
-        </p:spPr>
-        <p:txBody>
-          <a:bodyPr wrap="square">
-            <a:spAutoFit/>
-          </a:bodyPr>
-          <a:lstStyle/>
-          <a:p>
-            <a:pPr algn="ctr"/>
-            <a:r>
-              <a:rPr sz="3600" b="1">
-                <a:solidFill>
-                  <a:srgbClr val="FFFFFF"/>
-                </a:solidFill>
-              </a:rPr>
-              <a:t>Try it next</a:t>
-            </a:r>
-          </a:p>
-        </p:txBody>
-      </p:sp>
-      <p:sp>
-        <p:nvSpPr>
-          <p:cNvPr id="3" name="Rectangle 2"/>
-          <p:cNvSpPr/>
-          <p:nvPr/>
-        </p:nvSpPr>
-        <p:spPr>
-          <a:xfrm>
-            <a:off x="731520" y="2514600"/>
-            <a:ext cx="10698480" cy="36576"/>
-          </a:xfrm>
-          <a:prstGeom prst="rect">
-            <a:avLst/>
-          </a:prstGeom>
-          <a:solidFill>
-            <a:srgbClr val="A1A1AA"/>
-          </a:solidFill>
-          <a:ln>
-            <a:noFill/>
-          </a:ln>
-        </p:spPr>
-        <p:style>
-          <a:lnRef idx="1">
-            <a:schemeClr val="accent1"/>
-          </a:lnRef>
-          <a:fillRef idx="3">
-            <a:schemeClr val="accent1"/>
-          </a:fillRef>
-          <a:effectRef idx="2">
-            <a:schemeClr val="accent1"/>
-          </a:effectRef>
-          <a:fontRef idx="minor">
-            <a:schemeClr val="lt1"/>
-          </a:fontRef>
-        </p:style>
-        <p:txBody>
-          <a:bodyPr rtlCol="0" anchor="ctr"/>
-          <a:lstStyle/>
-          <a:p>
-            <a:pPr algn="ctr"/>
-          </a:p>
-        </p:txBody>
-      </p:sp>
-      <p:sp>
-        <p:nvSpPr>
-          <p:cNvPr id="4" name="TextBox 3"/>
-          <p:cNvSpPr txBox="1"/>
-          <p:nvPr/>
-        </p:nvSpPr>
-        <p:spPr>
-          <a:xfrm>
-            <a:off x="914400" y="2697480"/>
-            <a:ext cx="10332720" cy="640080"/>
-          </a:xfrm>
-          <a:prstGeom prst="rect">
-            <a:avLst/>
-          </a:prstGeom>
-          <a:noFill/>
-        </p:spPr>
-        <p:txBody>
-          <a:bodyPr wrap="square">
-            <a:spAutoFit/>
-          </a:bodyPr>
-          <a:lstStyle/>
-          <a:p>
-            <a:pPr algn="ctr"/>
-            <a:r>
-              <a:rPr sz="1800" b="0">
-                <a:solidFill>
-                  <a:srgbClr val="FFFFFF"/>
-                </a:solidFill>
-              </a:rPr>
-              <a:t>Complete the hands-on exercise in this chapter.</a:t>
-            </a:r>
-          </a:p>
-        </p:txBody>
-      </p:sp>
-      <p:sp>
-        <p:nvSpPr>
-          <p:cNvPr id="5" name="TextBox 4"/>
-          <p:cNvSpPr txBox="1"/>
-          <p:nvPr/>
-        </p:nvSpPr>
-        <p:spPr>
-          <a:xfrm>
-            <a:off x="914400" y="3429000"/>
-            <a:ext cx="10332720" cy="640080"/>
-          </a:xfrm>
-          <a:prstGeom prst="rect">
-            <a:avLst/>
-          </a:prstGeom>
-          <a:noFill/>
-        </p:spPr>
-        <p:txBody>
-          <a:bodyPr wrap="square">
-            <a:spAutoFit/>
-          </a:bodyPr>
-          <a:lstStyle/>
-          <a:p>
-            <a:pPr algn="ctr"/>
-            <a:r>
-              <a:rPr sz="2000" b="0">
-                <a:solidFill>
-                  <a:srgbClr val="A1A1AA"/>
-                </a:solidFill>
-              </a:rPr>
-              <a:t>Then continue to Chapter 2 →</a:t>
-            </a:r>
-          </a:p>
-        </p:txBody>
-      </p:sp>
-      <p:sp>
-        <p:nvSpPr>
-          <p:cNvPr id="6" name="TextBox 5"/>
-          <p:cNvSpPr txBox="1"/>
-          <p:nvPr/>
-        </p:nvSpPr>
-        <p:spPr>
-          <a:xfrm>
-            <a:off x="914400" y="4572000"/>
-            <a:ext cx="10332720" cy="640080"/>
-          </a:xfrm>
-          <a:prstGeom prst="rect">
-            <a:avLst/>
-          </a:prstGeom>
-          <a:noFill/>
-        </p:spPr>
-        <p:txBody>
-          <a:bodyPr wrap="square">
-            <a:spAutoFit/>
-          </a:bodyPr>
-          <a:lstStyle/>
-          <a:p>
-            <a:pPr algn="ctr"/>
-            <a:r>
-              <a:rPr sz="2200" b="1">
-                <a:solidFill>
-                  <a:srgbClr val="A1A1AA"/>
-                </a:solidFill>
-              </a:rPr>
-              <a:t>academy.kspl.tech</a:t>
-            </a:r>
-          </a:p>
-        </p:txBody>
-      </p:sp>
-      <p:sp>
-        <p:nvSpPr>
-          <p:cNvPr id="7" name="TextBox 6"/>
-          <p:cNvSpPr txBox="1"/>
-          <p:nvPr/>
-        </p:nvSpPr>
-        <p:spPr>
-          <a:xfrm>
-            <a:off x="731520" y="6263640"/>
-            <a:ext cx="10698480" cy="365760"/>
-          </a:xfrm>
-          <a:prstGeom prst="rect">
-            <a:avLst/>
-          </a:prstGeom>
-          <a:noFill/>
-        </p:spPr>
-        <p:txBody>
-          <a:bodyPr wrap="square">
-            <a:spAutoFit/>
-          </a:bodyPr>
-          <a:lstStyle/>
-          <a:p>
-            <a:pPr algn="l"/>
-            <a:r>
-              <a:rPr sz="1000" b="0">
-                <a:solidFill>
-                  <a:srgbClr val="A1A1AA"/>
-                </a:solidFill>
-              </a:rPr>
-              <a:t>academy.kspl.tech | Koenig AI Academy</a:t>
-            </a:r>
-          </a:p>
-        </p:txBody>
-      </p:sp>
-    </p:spTree>
-  </p:cSld>
-  <p:clrMapOvr>
-    <a:masterClrMapping/>
-  </p:clrMapOvr>
-</p:sld>
-</file>
-
 <file path=ppt/slides/slide2.xml><?xml version="1.0" encoding="utf-8"?>
 <p:sld xmlns:a="http://schemas.openxmlformats.org/drawingml/2006/main" xmlns:p="http://schemas.openxmlformats.org/presentationml/2006/main" xmlns:r="http://schemas.openxmlformats.org/officeDocument/2006/relationships">
   <p:cSld>
@@ -4227,7 +3781,7 @@
                   <a:srgbClr val="FFFFFF"/>
                 </a:solidFill>
               </a:rPr>
-              <a:t>  Model access: 200+ models including Gemini 3.1 Pro/Flash, Gemma 4, Anthropic Claude (Opus/Sonnet/Haiku), and third-party</a:t>
+              <a:t>  Model access: 200+ models including Gemini 3.1 Pro/Flash, Gemma 4, Anthropic Claude (Opus/Sonnet/Haiku), and t</a:t>
             </a:r>
           </a:p>
         </p:txBody>
@@ -4398,7 +3952,7 @@
                   <a:srgbClr val="FFFFFF"/>
                 </a:solidFill>
               </a:rPr>
-              <a:t>  When Google announced GEAP, industry coverage focused on the new features: sub-agent networks, Memory Bank, Agent Identi</a:t>
+              <a:t>  When Google announced GEAP, industry coverage focused on the new features: sub-agent…</a:t>
             </a:r>
           </a:p>
         </p:txBody>
@@ -4432,7 +3986,7 @@
                   <a:srgbClr val="FFFFFF"/>
                 </a:solidFill>
               </a:rPr>
-              <a:t>  That is a major commitment. It means if you are using Vertex AI Pipelines, Vertex AI Evaluation, or any other standalone</a:t>
+              <a:t>  The buried lede was the strategic declaration at the end of the announcement: "All…</a:t>
             </a:r>
           </a:p>
         </p:txBody>
@@ -4466,7 +4020,7 @@
                   <a:srgbClr val="FFFFFF"/>
                 </a:solidFill>
               </a:rPr>
-              <a:t>  Whether that bet pays off for you depends on your use case. This chapter explains the architecture so you can make that </a:t>
+              <a:t>  That is a major commitment.</a:t>
             </a:r>
           </a:p>
         </p:txBody>
@@ -4474,6 +4028,40 @@
       <p:sp>
         <p:nvSpPr>
           <p:cNvPr id="7" name="TextBox 6"/>
+          <p:cNvSpPr txBox="1"/>
+          <p:nvPr/>
+        </p:nvSpPr>
+        <p:spPr>
+          <a:xfrm>
+            <a:off x="731520" y="4754880"/>
+            <a:ext cx="10698480" cy="960120"/>
+          </a:xfrm>
+          <a:prstGeom prst="rect">
+            <a:avLst/>
+          </a:prstGeom>
+          <a:noFill/>
+        </p:spPr>
+        <p:txBody>
+          <a:bodyPr wrap="square">
+            <a:spAutoFit/>
+          </a:bodyPr>
+          <a:lstStyle/>
+          <a:p>
+            <a:pPr algn="l"/>
+            <a:r>
+              <a:rPr sz="1600" b="0">
+                <a:solidFill>
+                  <a:srgbClr val="FFFFFF"/>
+                </a:solidFill>
+              </a:rPr>
+              <a:t>  It means if you are using Vertex AI Pipelines, Vertex AI Evaluation, or any other…</a:t>
+            </a:r>
+          </a:p>
+        </p:txBody>
+      </p:sp>
+      <p:sp>
+        <p:nvSpPr>
+          <p:cNvPr id="8" name="TextBox 7"/>
           <p:cNvSpPr txBox="1"/>
           <p:nvPr/>
         </p:nvSpPr>
@@ -4637,7 +4225,7 @@
                   <a:srgbClr val="FFFFFF"/>
                 </a:solidFill>
               </a:rPr>
-              <a:t>  GEAP is organized into four operational domains. Every feature belongs to one of them. Knowing which pillar a feature be</a:t>
+              <a:t>  Pillar 1: Build</a:t>
             </a:r>
           </a:p>
         </p:txBody>
@@ -4671,7 +4259,7 @@
                   <a:srgbClr val="FFFFFF"/>
                 </a:solidFill>
               </a:rPr>
-              <a:t>  Pillar 1: Build</a:t>
+              <a:t>  Agent Garden: pre-built agent templates for common enterprise tasks (code modernization, invoice processing, f</a:t>
             </a:r>
           </a:p>
         </p:txBody>
@@ -4705,7 +4293,7 @@
                   <a:srgbClr val="FFFFFF"/>
                 </a:solidFill>
               </a:rPr>
-              <a:t>  Build is where you create agents. There are two entry points:</a:t>
+              <a:t>  Workspaces: sandboxed environments where agents can execute bash commands and manage files. This is GEAP's ans</a:t>
             </a:r>
           </a:p>
         </p:txBody>
@@ -4739,7 +4327,7 @@
                   <a:srgbClr val="FFFFFF"/>
                 </a:solidFill>
               </a:rPr>
-              <a:t>  Agent Studio is a low-code, visual interface. You drag components, define tools from a catalogue, set an instruction pro</a:t>
+              <a:t>  Pillar 2: Scale</a:t>
             </a:r>
           </a:p>
         </p:txBody>
@@ -4910,7 +4498,7 @@
                   <a:srgbClr val="FFFFFF"/>
                 </a:solidFill>
               </a:rPr>
-              <a:t>  The four pillars are comprehensive enough that it is easy to assume GEAP is everything. Three things it is not:</a:t>
+              <a:t>  The four pillars are comprehensive enough that it is easy to assume GEAP is everything.</a:t>
             </a:r>
           </a:p>
         </p:txBody>
@@ -4944,7 +4532,7 @@
                   <a:srgbClr val="FFFFFF"/>
                 </a:solidFill>
               </a:rPr>
-              <a:t>  It is not model-agnostic in practice. GEAP supports 200+ models including Claude and open models. But the tightest integ</a:t>
+              <a:t>  It is not model-agnostic in practice.</a:t>
             </a:r>
           </a:p>
         </p:txBody>
@@ -4978,7 +4566,7 @@
                   <a:srgbClr val="FFFFFF"/>
                 </a:solidFill>
               </a:rPr>
-              <a:t>  It is not open-source. The ADK is open-source (Apache 2.0). The runtime, Memory Bank, Agent Gateway, and Govern features</a:t>
+              <a:t>  GEAP supports 200+ models including Claude and open models.</a:t>
             </a:r>
           </a:p>
         </p:txBody>
@@ -5012,7 +4600,7 @@
                   <a:srgbClr val="FFFFFF"/>
                 </a:solidFill>
               </a:rPr>
-              <a:t>  It is not Dialogflow CX rebranded. Dialogflow CX was a flow-based, deterministic dialogue manager. GEAP's agents reason </a:t>
+              <a:t>  But the tightest integrations — Memory Bank, Agent Runtime telemetry, Agent Optimizer —…</a:t>
             </a:r>
           </a:p>
         </p:txBody>
@@ -5183,7 +4771,7 @@
                   <a:srgbClr val="FFFFFF"/>
                 </a:solidFill>
               </a:rPr>
-              <a:t>  Here is the component map for a typical customer-support agent on GEAP. Read this as a data-flow diagram, left to right:</a:t>
+              <a:t>  Here is the component map for a typical customer-support agent on GEAP.</a:t>
             </a:r>
           </a:p>
         </p:txBody>
@@ -5217,7 +4805,7 @@
                   <a:srgbClr val="FFFFFF"/>
                 </a:solidFill>
               </a:rPr>
-              <a:t>  Every box in this diagram is a managed GCP service. The only code you write is the Agent itself and the tool implementat</a:t>
+              <a:t>  Every box in this diagram is a managed GCP service.</a:t>
             </a:r>
           </a:p>
         </p:txBody>
@@ -5251,7 +4839,7 @@
                   <a:srgbClr val="FFFFFF"/>
                 </a:solidFill>
               </a:rPr>
-              <a:t>  question: "Which GEAP pillar contains Memory Bank and Agent Sessions?",</a:t>
+              <a:t>  The only code you write is the Agent itself and the tool implementations.</a:t>
             </a:r>
           </a:p>
         </p:txBody>
@@ -5285,7 +4873,7 @@
                   <a:srgbClr val="FFFFFF"/>
                 </a:solidFill>
               </a:rPr>
-              <a:t>  explanation: "Memory Bank and Agent Sessions are Scale features — they exist to make agents production-grade by providin</a:t>
+              <a:t>  That is the core value proposition — and the core lock-in.</a:t>
             </a:r>
           </a:p>
         </p:txBody>
@@ -5456,7 +5044,7 @@
                   <a:srgbClr val="FFFFFF"/>
                 </a:solidFill>
               </a:rPr>
-              <a:t>  GEAP's consolidation narrative is compelling, but it carries a real cost: surface area. When Vertex AI was a collection </a:t>
+              <a:t>  GEAP's consolidation narrative is compelling, but it carries a real cost: surface area.</a:t>
             </a:r>
           </a:p>
         </p:txBody>
@@ -5490,7 +5078,7 @@
                   <a:srgbClr val="FFFFFF"/>
                 </a:solidFill>
               </a:rPr>
-              <a:t>  For a solo developer building a weekend project, GEAP is overkill. The four-pillar architecture is enterprise governance</a:t>
+              <a:t>  When Vertex AI was a collection of loosely coupled services, a team could adopt Vertex…</a:t>
             </a:r>
           </a:p>
         </p:txBody>
@@ -5524,7 +5112,7 @@
                   <a:srgbClr val="FFFFFF"/>
                 </a:solidFill>
               </a:rPr>
-              <a:t>  The more honest framing: GEAP is the right platform when you need at least two of the four pillars in production. If you</a:t>
+              <a:t>  Now that everything is GEAP, the conceptual overhead of the platform is always in scope.</a:t>
             </a:r>
           </a:p>
         </p:txBody>
@@ -5532,6 +5120,40 @@
       <p:sp>
         <p:nvSpPr>
           <p:cNvPr id="7" name="TextBox 6"/>
+          <p:cNvSpPr txBox="1"/>
+          <p:nvPr/>
+        </p:nvSpPr>
+        <p:spPr>
+          <a:xfrm>
+            <a:off x="731520" y="4754880"/>
+            <a:ext cx="10698480" cy="960120"/>
+          </a:xfrm>
+          <a:prstGeom prst="rect">
+            <a:avLst/>
+          </a:prstGeom>
+          <a:noFill/>
+        </p:spPr>
+        <p:txBody>
+          <a:bodyPr wrap="square">
+            <a:spAutoFit/>
+          </a:bodyPr>
+          <a:lstStyle/>
+          <a:p>
+            <a:pPr algn="l"/>
+            <a:r>
+              <a:rPr sz="1600" b="0">
+                <a:solidFill>
+                  <a:srgbClr val="FFFFFF"/>
+                </a:solidFill>
+              </a:rPr>
+              <a:t>  For a solo developer building a weekend project, GEAP is overkill.</a:t>
+            </a:r>
+          </a:p>
+        </p:txBody>
+      </p:sp>
+      <p:sp>
+        <p:nvSpPr>
+          <p:cNvPr id="8" name="TextBox 7"/>
           <p:cNvSpPr txBox="1"/>
           <p:nvPr/>
         </p:nvSpPr>
@@ -5597,8 +5219,8 @@
         </p:nvSpPr>
         <p:spPr>
           <a:xfrm>
-            <a:off x="731520" y="411480"/>
-            <a:ext cx="10698480" cy="1005840"/>
+            <a:off x="914400" y="1645920"/>
+            <a:ext cx="10332720" cy="822960"/>
           </a:xfrm>
           <a:prstGeom prst="rect">
             <a:avLst/>
@@ -5611,14 +5233,14 @@
           </a:bodyPr>
           <a:lstStyle/>
           <a:p>
-            <a:pPr algn="l"/>
-            <a:r>
-              <a:rPr sz="2600" b="1">
+            <a:pPr algn="ctr"/>
+            <a:r>
+              <a:rPr sz="3600" b="1">
                 <a:solidFill>
                   <a:srgbClr val="FFFFFF"/>
                 </a:solidFill>
               </a:rPr>
-              <a:t>Hands-on exercise</a:t>
+              <a:t>Try it next</a:t>
             </a:r>
           </a:p>
         </p:txBody>
@@ -5631,7 +5253,7 @@
         </p:nvSpPr>
         <p:spPr>
           <a:xfrm>
-            <a:off x="731520" y="1417320"/>
+            <a:off x="731520" y="2514600"/>
             <a:ext cx="10698480" cy="36576"/>
           </a:xfrm>
           <a:prstGeom prst="rect">
@@ -5674,8 +5296,8 @@
         </p:nvSpPr>
         <p:spPr>
           <a:xfrm>
-            <a:off x="731520" y="1600200"/>
-            <a:ext cx="10698480" cy="960120"/>
+            <a:off x="914400" y="2697480"/>
+            <a:ext cx="10332720" cy="640080"/>
           </a:xfrm>
           <a:prstGeom prst="rect">
             <a:avLst/>
@@ -5688,14 +5310,14 @@
           </a:bodyPr>
           <a:lstStyle/>
           <a:p>
-            <a:pPr algn="l"/>
-            <a:r>
-              <a:rPr sz="1600" b="0">
+            <a:pPr algn="ctr"/>
+            <a:r>
+              <a:rPr sz="1800" b="0">
                 <a:solidFill>
                   <a:srgbClr val="FFFFFF"/>
                 </a:solidFill>
               </a:rPr>
-              <a:t>  Draw the GEAP component map for your use case.</a:t>
+              <a:t>Complete the hands-on exercise in this chapter.</a:t>
             </a:r>
           </a:p>
         </p:txBody>
@@ -5708,8 +5330,8 @@
         </p:nvSpPr>
         <p:spPr>
           <a:xfrm>
-            <a:off x="731520" y="2651760"/>
-            <a:ext cx="10698480" cy="960120"/>
+            <a:off x="914400" y="3429000"/>
+            <a:ext cx="10332720" cy="640080"/>
           </a:xfrm>
           <a:prstGeom prst="rect">
             <a:avLst/>
@@ -5722,14 +5344,14 @@
           </a:bodyPr>
           <a:lstStyle/>
           <a:p>
-            <a:pPr algn="l"/>
-            <a:r>
-              <a:rPr sz="1600" b="0">
-                <a:solidFill>
-                  <a:srgbClr val="FFFFFF"/>
+            <a:pPr algn="ctr"/>
+            <a:r>
+              <a:rPr sz="2000" b="0">
+                <a:solidFill>
+                  <a:srgbClr val="A1A1AA"/>
                 </a:solidFill>
               </a:rPr>
-              <a:t>  Pick a real (or plausible) agent you want to build. On paper or in a diagramming tool:</a:t>
+              <a:t>Then continue to Chapter 2 →</a:t>
             </a:r>
           </a:p>
         </p:txBody>
@@ -5742,8 +5364,8 @@
         </p:nvSpPr>
         <p:spPr>
           <a:xfrm>
-            <a:off x="731520" y="3703320"/>
-            <a:ext cx="10698480" cy="960120"/>
+            <a:off x="914400" y="4572000"/>
+            <a:ext cx="10332720" cy="640080"/>
           </a:xfrm>
           <a:prstGeom prst="rect">
             <a:avLst/>
@@ -5756,14 +5378,14 @@
           </a:bodyPr>
           <a:lstStyle/>
           <a:p>
-            <a:pPr algn="l"/>
-            <a:r>
-              <a:rPr sz="1600" b="0">
-                <a:solidFill>
-                  <a:srgbClr val="FFFFFF"/>
+            <a:pPr algn="ctr"/>
+            <a:r>
+              <a:rPr sz="2200" b="1">
+                <a:solidFill>
+                  <a:srgbClr val="A1A1AA"/>
                 </a:solidFill>
               </a:rPr>
-              <a:t>  Draw the data flow from user request to response.</a:t>
+              <a:t>academy.kspl.tech</a:t>
             </a:r>
           </a:p>
         </p:txBody>
@@ -5771,40 +5393,6 @@
       <p:sp>
         <p:nvSpPr>
           <p:cNvPr id="7" name="TextBox 6"/>
-          <p:cNvSpPr txBox="1"/>
-          <p:nvPr/>
-        </p:nvSpPr>
-        <p:spPr>
-          <a:xfrm>
-            <a:off x="731520" y="4754880"/>
-            <a:ext cx="10698480" cy="960120"/>
-          </a:xfrm>
-          <a:prstGeom prst="rect">
-            <a:avLst/>
-          </a:prstGeom>
-          <a:noFill/>
-        </p:spPr>
-        <p:txBody>
-          <a:bodyPr wrap="square">
-            <a:spAutoFit/>
-          </a:bodyPr>
-          <a:lstStyle/>
-          <a:p>
-            <a:pPr algn="l"/>
-            <a:r>
-              <a:rPr sz="1600" b="0">
-                <a:solidFill>
-                  <a:srgbClr val="FFFFFF"/>
-                </a:solidFill>
-              </a:rPr>
-              <a:t>  For each GEAP component you would use, label which pillar it belongs to.</a:t>
-            </a:r>
-          </a:p>
-        </p:txBody>
-      </p:sp>
-      <p:sp>
-        <p:nvSpPr>
-          <p:cNvPr id="8" name="TextBox 7"/>
           <p:cNvSpPr txBox="1"/>
           <p:nvPr/>
         </p:nvSpPr>

</xml_diff>

<commit_message>
auto: vault-sync 2026-05-26T10:39:41Z (9 files)
</commit_message>
<xml_diff>
--- a/vault/courses/gemini-enterprise-agents/ch01-slides.pptx
+++ b/vault/courses/gemini-enterprise-agents/ch01-slides.pptx
@@ -12,9 +12,6 @@
     <p:sldId id="260" r:id="rId11"/>
     <p:sldId id="261" r:id="rId12"/>
     <p:sldId id="262" r:id="rId13"/>
-    <p:sldId id="263" r:id="rId14"/>
-    <p:sldId id="264" r:id="rId15"/>
-    <p:sldId id="265" r:id="rId16"/>
   </p:sldIdLst>
   <p:sldSz cx="12191695" cy="6858000" type="screen4x3"/>
   <p:notesSz cx="6858000" cy="9144000"/>
@@ -3107,57 +3104,14 @@
       <p:grpSpPr/>
       <p:sp>
         <p:nvSpPr>
-          <p:cNvPr id="2" name="Rectangle 1"/>
-          <p:cNvSpPr/>
-          <p:nvPr/>
-        </p:nvSpPr>
-        <p:spPr>
-          <a:xfrm>
-            <a:off x="0" y="0"/>
-            <a:ext cx="109728" cy="6858000"/>
-          </a:xfrm>
-          <a:prstGeom prst="rect">
-            <a:avLst/>
-          </a:prstGeom>
-          <a:solidFill>
-            <a:srgbClr val="60A5FA"/>
-          </a:solidFill>
-          <a:ln>
-            <a:noFill/>
-          </a:ln>
-        </p:spPr>
-        <p:style>
-          <a:lnRef idx="1">
-            <a:schemeClr val="accent1"/>
-          </a:lnRef>
-          <a:fillRef idx="3">
-            <a:schemeClr val="accent1"/>
-          </a:fillRef>
-          <a:effectRef idx="2">
-            <a:schemeClr val="accent1"/>
-          </a:effectRef>
-          <a:fontRef idx="minor">
-            <a:schemeClr val="lt1"/>
-          </a:fontRef>
-        </p:style>
-        <p:txBody>
-          <a:bodyPr rtlCol="0" anchor="ctr"/>
-          <a:lstStyle/>
-          <a:p>
-            <a:pPr algn="ctr"/>
-          </a:p>
-        </p:txBody>
-      </p:sp>
-      <p:sp>
-        <p:nvSpPr>
-          <p:cNvPr id="3" name="TextBox 2"/>
+          <p:cNvPr id="2" name="TextBox 1"/>
           <p:cNvSpPr txBox="1"/>
           <p:nvPr/>
         </p:nvSpPr>
         <p:spPr>
           <a:xfrm>
-            <a:off x="594360" y="438912"/>
-            <a:ext cx="10881360" cy="1005840"/>
+            <a:off x="914400" y="1828800"/>
+            <a:ext cx="10332720" cy="2286000"/>
           </a:xfrm>
           <a:prstGeom prst="rect">
             <a:avLst/>
@@ -3165,19 +3119,18 @@
           <a:noFill/>
         </p:spPr>
         <p:txBody>
-          <a:bodyPr wrap="none">
+          <a:bodyPr wrap="square">
             <a:spAutoFit/>
           </a:bodyPr>
           <a:lstStyle/>
           <a:p>
-            <a:pPr algn="l">
-              <a:defRPr sz="3400" b="1">
+            <a:pPr algn="ctr"/>
+            <a:r>
+              <a:rPr sz="3400" b="1">
                 <a:solidFill>
                   <a:srgbClr val="FFFFFF"/>
                 </a:solidFill>
-              </a:defRPr>
-            </a:pPr>
-            <a:r>
+              </a:rPr>
               <a:t>What Gemini Enterprise Agent Platform Actually Is (and Isn't)</a:t>
             </a:r>
           </a:p>
@@ -3185,14 +3138,14 @@
       </p:sp>
       <p:sp>
         <p:nvSpPr>
-          <p:cNvPr id="4" name="TextBox 3"/>
+          <p:cNvPr id="3" name="TextBox 2"/>
           <p:cNvSpPr txBox="1"/>
           <p:nvPr/>
         </p:nvSpPr>
         <p:spPr>
           <a:xfrm>
-            <a:off x="621792" y="1353312"/>
-            <a:ext cx="10607040" cy="411480"/>
+            <a:off x="914400" y="4297680"/>
+            <a:ext cx="10332720" cy="457200"/>
           </a:xfrm>
           <a:prstGeom prst="rect">
             <a:avLst/>
@@ -3200,34 +3153,33 @@
           <a:noFill/>
         </p:spPr>
         <p:txBody>
-          <a:bodyPr wrap="none">
+          <a:bodyPr wrap="square">
             <a:spAutoFit/>
           </a:bodyPr>
           <a:lstStyle/>
           <a:p>
-            <a:pPr>
-              <a:defRPr sz="1400">
-                <a:solidFill>
-                  <a:srgbClr val="D4D4D8"/>
-                </a:solidFill>
-              </a:defRPr>
-            </a:pPr>
-            <a:r>
-              <a:t>Chapter 01 · Gemini Enterprise Agents</a:t>
-            </a:r>
-          </a:p>
-        </p:txBody>
-      </p:sp>
-      <p:sp>
-        <p:nvSpPr>
-          <p:cNvPr id="5" name="TextBox 4"/>
+            <a:pPr algn="ctr"/>
+            <a:r>
+              <a:rPr sz="1600" b="0">
+                <a:solidFill>
+                  <a:srgbClr val="A1A1AA"/>
+                </a:solidFill>
+              </a:rPr>
+              <a:t>2026-04-30</a:t>
+            </a:r>
+          </a:p>
+        </p:txBody>
+      </p:sp>
+      <p:sp>
+        <p:nvSpPr>
+          <p:cNvPr id="4" name="TextBox 3"/>
           <p:cNvSpPr txBox="1"/>
           <p:nvPr/>
         </p:nvSpPr>
         <p:spPr>
           <a:xfrm>
-            <a:off x="804672" y="1965960"/>
-            <a:ext cx="10652760" cy="4069080"/>
+            <a:off x="731520" y="6263640"/>
+            <a:ext cx="10698480" cy="365760"/>
           </a:xfrm>
           <a:prstGeom prst="rect">
             <a:avLst/>
@@ -3240,368 +3192,14 @@
           </a:bodyPr>
           <a:lstStyle/>
           <a:p>
-            <a:pPr marL="0">
-              <a:lnSpc>
-                <a:spcPct val="108000"/>
-              </a:lnSpc>
-              <a:spcAft>
-                <a:spcPts val="1100"/>
-              </a:spcAft>
-              <a:defRPr sz="2100">
-                <a:solidFill>
-                  <a:srgbClr val="FFFFFF"/>
-                </a:solidFill>
-                <a:latin typeface="Aptos"/>
-              </a:defRPr>
-            </a:pPr>
-            <a:r>
-              <a:t>GA on 23 April 2026 as Google's enterprise agent consolidation layer</a:t>
-            </a:r>
-          </a:p>
-          <a:p>
-            <a:pPr marL="0">
-              <a:lnSpc>
-                <a:spcPct val="108000"/>
-              </a:lnSpc>
-              <a:spcAft>
-                <a:spcPts val="1100"/>
-              </a:spcAft>
-              <a:defRPr sz="2100">
-                <a:solidFill>
-                  <a:srgbClr val="D4D4D8"/>
-                </a:solidFill>
-                <a:latin typeface="Aptos"/>
-              </a:defRPr>
-            </a:pPr>
-            <a:r>
-              <a:t>Organized around Build, Scale, Govern, and Optimize</a:t>
-            </a:r>
-          </a:p>
-          <a:p>
-            <a:pPr marL="0">
-              <a:lnSpc>
-                <a:spcPct val="108000"/>
-              </a:lnSpc>
-              <a:spcAft>
-                <a:spcPts val="1100"/>
-              </a:spcAft>
-              <a:defRPr sz="2100">
-                <a:solidFill>
-                  <a:srgbClr val="D4D4D8"/>
-                </a:solidFill>
-                <a:latin typeface="Aptos"/>
-              </a:defRPr>
-            </a:pPr>
-            <a:r>
+            <a:pPr algn="l"/>
+            <a:r>
+              <a:rPr sz="1000" b="0">
+                <a:solidFill>
+                  <a:srgbClr val="A1A1AA"/>
+                </a:solidFill>
+              </a:rPr>
               <a:t>academy.kspl.tech | Koenig AI Academy</a:t>
-            </a:r>
-          </a:p>
-        </p:txBody>
-      </p:sp>
-      <p:sp>
-        <p:nvSpPr>
-          <p:cNvPr id="6" name="TextBox 5"/>
-          <p:cNvSpPr txBox="1"/>
-          <p:nvPr/>
-        </p:nvSpPr>
-        <p:spPr>
-          <a:xfrm>
-            <a:off x="502920" y="6446520"/>
-            <a:ext cx="11201400" cy="228600"/>
-          </a:xfrm>
-          <a:prstGeom prst="rect">
-            <a:avLst/>
-          </a:prstGeom>
-          <a:noFill/>
-        </p:spPr>
-        <p:txBody>
-          <a:bodyPr wrap="none">
-            <a:spAutoFit/>
-          </a:bodyPr>
-          <a:lstStyle/>
-          <a:p>
-            <a:pPr algn="r">
-              <a:defRPr sz="800">
-                <a:solidFill>
-                  <a:srgbClr val="A1A1AA"/>
-                </a:solidFill>
-              </a:defRPr>
-            </a:pPr>
-            <a:r>
-              <a:t>academy.kspl.tech | Koenig AI Academy · 01</a:t>
-            </a:r>
-          </a:p>
-        </p:txBody>
-      </p:sp>
-    </p:spTree>
-  </p:cSld>
-  <p:clrMapOvr>
-    <a:masterClrMapping/>
-  </p:clrMapOvr>
-</p:sld>
-</file>
-
-<file path=ppt/slides/slide10.xml><?xml version="1.0" encoding="utf-8"?>
-<p:sld xmlns:a="http://schemas.openxmlformats.org/drawingml/2006/main" xmlns:p="http://schemas.openxmlformats.org/presentationml/2006/main" xmlns:r="http://schemas.openxmlformats.org/officeDocument/2006/relationships">
-  <p:cSld>
-    <p:bg>
-      <p:bgPr>
-        <a:solidFill>
-          <a:srgbClr val="18181B"/>
-        </a:solidFill>
-        <a:effectLst/>
-      </p:bgPr>
-    </p:bg>
-    <p:spTree>
-      <p:nvGrpSpPr>
-        <p:cNvPr id="1" name=""/>
-        <p:cNvGrpSpPr/>
-        <p:nvPr/>
-      </p:nvGrpSpPr>
-      <p:grpSpPr/>
-      <p:sp>
-        <p:nvSpPr>
-          <p:cNvPr id="2" name="Rectangle 1"/>
-          <p:cNvSpPr/>
-          <p:nvPr/>
-        </p:nvSpPr>
-        <p:spPr>
-          <a:xfrm>
-            <a:off x="0" y="0"/>
-            <a:ext cx="109728" cy="6858000"/>
-          </a:xfrm>
-          <a:prstGeom prst="rect">
-            <a:avLst/>
-          </a:prstGeom>
-          <a:solidFill>
-            <a:srgbClr val="34D399"/>
-          </a:solidFill>
-          <a:ln>
-            <a:noFill/>
-          </a:ln>
-        </p:spPr>
-        <p:style>
-          <a:lnRef idx="1">
-            <a:schemeClr val="accent1"/>
-          </a:lnRef>
-          <a:fillRef idx="3">
-            <a:schemeClr val="accent1"/>
-          </a:fillRef>
-          <a:effectRef idx="2">
-            <a:schemeClr val="accent1"/>
-          </a:effectRef>
-          <a:fontRef idx="minor">
-            <a:schemeClr val="lt1"/>
-          </a:fontRef>
-        </p:style>
-        <p:txBody>
-          <a:bodyPr rtlCol="0" anchor="ctr"/>
-          <a:lstStyle/>
-          <a:p>
-            <a:pPr algn="ctr"/>
-          </a:p>
-        </p:txBody>
-      </p:sp>
-      <p:sp>
-        <p:nvSpPr>
-          <p:cNvPr id="3" name="TextBox 2"/>
-          <p:cNvSpPr txBox="1"/>
-          <p:nvPr/>
-        </p:nvSpPr>
-        <p:spPr>
-          <a:xfrm>
-            <a:off x="594360" y="438912"/>
-            <a:ext cx="10881360" cy="1005840"/>
-          </a:xfrm>
-          <a:prstGeom prst="rect">
-            <a:avLst/>
-          </a:prstGeom>
-          <a:noFill/>
-        </p:spPr>
-        <p:txBody>
-          <a:bodyPr wrap="none">
-            <a:spAutoFit/>
-          </a:bodyPr>
-          <a:lstStyle/>
-          <a:p>
-            <a:pPr algn="l">
-              <a:defRPr sz="3000" b="1">
-                <a:solidFill>
-                  <a:srgbClr val="FFFFFF"/>
-                </a:solidFill>
-              </a:defRPr>
-            </a:pPr>
-            <a:r>
-              <a:t>Try It Next</a:t>
-            </a:r>
-          </a:p>
-        </p:txBody>
-      </p:sp>
-      <p:sp>
-        <p:nvSpPr>
-          <p:cNvPr id="4" name="TextBox 3"/>
-          <p:cNvSpPr txBox="1"/>
-          <p:nvPr/>
-        </p:nvSpPr>
-        <p:spPr>
-          <a:xfrm>
-            <a:off x="621792" y="1353312"/>
-            <a:ext cx="10607040" cy="411480"/>
-          </a:xfrm>
-          <a:prstGeom prst="rect">
-            <a:avLst/>
-          </a:prstGeom>
-          <a:noFill/>
-        </p:spPr>
-        <p:txBody>
-          <a:bodyPr wrap="none">
-            <a:spAutoFit/>
-          </a:bodyPr>
-          <a:lstStyle/>
-          <a:p>
-            <a:pPr>
-              <a:defRPr sz="1400">
-                <a:solidFill>
-                  <a:srgbClr val="D4D4D8"/>
-                </a:solidFill>
-              </a:defRPr>
-            </a:pPr>
-            <a:r>
-              <a:t>Apply the platform map to your own use case</a:t>
-            </a:r>
-          </a:p>
-        </p:txBody>
-      </p:sp>
-      <p:sp>
-        <p:nvSpPr>
-          <p:cNvPr id="5" name="TextBox 4"/>
-          <p:cNvSpPr txBox="1"/>
-          <p:nvPr/>
-        </p:nvSpPr>
-        <p:spPr>
-          <a:xfrm>
-            <a:off x="804672" y="1965960"/>
-            <a:ext cx="10652760" cy="4069080"/>
-          </a:xfrm>
-          <a:prstGeom prst="rect">
-            <a:avLst/>
-          </a:prstGeom>
-          <a:noFill/>
-        </p:spPr>
-        <p:txBody>
-          <a:bodyPr wrap="square">
-            <a:spAutoFit/>
-          </a:bodyPr>
-          <a:lstStyle/>
-          <a:p>
-            <a:pPr marL="0">
-              <a:lnSpc>
-                <a:spcPct val="108000"/>
-              </a:lnSpc>
-              <a:spcAft>
-                <a:spcPts val="1100"/>
-              </a:spcAft>
-              <a:defRPr sz="1900">
-                <a:solidFill>
-                  <a:srgbClr val="FFFFFF"/>
-                </a:solidFill>
-                <a:latin typeface="Aptos"/>
-              </a:defRPr>
-            </a:pPr>
-            <a:r>
-              <a:t>Draw the data flow from user request to response for a real or plausible agent</a:t>
-            </a:r>
-          </a:p>
-          <a:p>
-            <a:pPr marL="0">
-              <a:lnSpc>
-                <a:spcPct val="108000"/>
-              </a:lnSpc>
-              <a:spcAft>
-                <a:spcPts val="1100"/>
-              </a:spcAft>
-              <a:defRPr sz="1900">
-                <a:solidFill>
-                  <a:srgbClr val="D4D4D8"/>
-                </a:solidFill>
-                <a:latin typeface="Aptos"/>
-              </a:defRPr>
-            </a:pPr>
-            <a:r>
-              <a:t>Label at least four GEAP components by Build, Scale, Govern, or Optimize</a:t>
-            </a:r>
-          </a:p>
-          <a:p>
-            <a:pPr marL="0">
-              <a:lnSpc>
-                <a:spcPct val="108000"/>
-              </a:lnSpc>
-              <a:spcAft>
-                <a:spcPts val="1100"/>
-              </a:spcAft>
-              <a:defRPr sz="1900">
-                <a:solidFill>
-                  <a:srgbClr val="D4D4D8"/>
-                </a:solidFill>
-                <a:latin typeface="Aptos"/>
-              </a:defRPr>
-            </a:pPr>
-            <a:r>
-              <a:t>Mark components you would not use and write one sentence explaining why</a:t>
-            </a:r>
-          </a:p>
-          <a:p>
-            <a:pPr marL="0">
-              <a:lnSpc>
-                <a:spcPct val="108000"/>
-              </a:lnSpc>
-              <a:spcAft>
-                <a:spcPts val="1100"/>
-              </a:spcAft>
-              <a:defRPr sz="1900">
-                <a:solidFill>
-                  <a:srgbClr val="D4D4D8"/>
-                </a:solidFill>
-                <a:latin typeface="Aptos"/>
-              </a:defRPr>
-            </a:pPr>
-            <a:r>
-              <a:t>Decide whether your use case requires at least two pillars; if not, question whether GEAP is the right platform</a:t>
-            </a:r>
-          </a:p>
-        </p:txBody>
-      </p:sp>
-      <p:sp>
-        <p:nvSpPr>
-          <p:cNvPr id="6" name="TextBox 5"/>
-          <p:cNvSpPr txBox="1"/>
-          <p:nvPr/>
-        </p:nvSpPr>
-        <p:spPr>
-          <a:xfrm>
-            <a:off x="502920" y="6446520"/>
-            <a:ext cx="11201400" cy="228600"/>
-          </a:xfrm>
-          <a:prstGeom prst="rect">
-            <a:avLst/>
-          </a:prstGeom>
-          <a:noFill/>
-        </p:spPr>
-        <p:txBody>
-          <a:bodyPr wrap="none">
-            <a:spAutoFit/>
-          </a:bodyPr>
-          <a:lstStyle/>
-          <a:p>
-            <a:pPr algn="r">
-              <a:defRPr sz="800">
-                <a:solidFill>
-                  <a:srgbClr val="A1A1AA"/>
-                </a:solidFill>
-              </a:defRPr>
-            </a:pPr>
-            <a:r>
-              <a:t>academy.kspl.tech | Koenig AI Academy · 10</a:t>
             </a:r>
           </a:p>
         </p:txBody>
@@ -3634,20 +3232,54 @@
       <p:grpSpPr/>
       <p:sp>
         <p:nvSpPr>
-          <p:cNvPr id="2" name="Rectangle 1"/>
+          <p:cNvPr id="2" name="TextBox 1"/>
+          <p:cNvSpPr txBox="1"/>
+          <p:nvPr/>
+        </p:nvSpPr>
+        <p:spPr>
+          <a:xfrm>
+            <a:off x="731520" y="411480"/>
+            <a:ext cx="10698480" cy="1005840"/>
+          </a:xfrm>
+          <a:prstGeom prst="rect">
+            <a:avLst/>
+          </a:prstGeom>
+          <a:noFill/>
+        </p:spPr>
+        <p:txBody>
+          <a:bodyPr wrap="square">
+            <a:spAutoFit/>
+          </a:bodyPr>
+          <a:lstStyle/>
+          <a:p>
+            <a:pPr algn="l"/>
+            <a:r>
+              <a:rPr sz="2800" b="1">
+                <a:solidFill>
+                  <a:srgbClr val="FFFFFF"/>
+                </a:solidFill>
+              </a:rPr>
+              <a:t>Key facts</a:t>
+            </a:r>
+          </a:p>
+        </p:txBody>
+      </p:sp>
+      <p:sp>
+        <p:nvSpPr>
+          <p:cNvPr id="3" name="Rectangle 2"/>
           <p:cNvSpPr/>
           <p:nvPr/>
         </p:nvSpPr>
         <p:spPr>
           <a:xfrm>
-            <a:off x="0" y="0"/>
-            <a:ext cx="109728" cy="6858000"/>
+            <a:off x="731520" y="1417320"/>
+            <a:ext cx="10698480" cy="36576"/>
           </a:xfrm>
           <a:prstGeom prst="rect">
             <a:avLst/>
           </a:prstGeom>
           <a:solidFill>
-            <a:srgbClr val="34D399"/>
+            <a:srgbClr val="A1A1AA"/>
           </a:solidFill>
           <a:ln>
             <a:noFill/>
@@ -3677,14 +3309,14 @@
       </p:sp>
       <p:sp>
         <p:nvSpPr>
-          <p:cNvPr id="3" name="TextBox 2"/>
+          <p:cNvPr id="4" name="TextBox 3"/>
           <p:cNvSpPr txBox="1"/>
           <p:nvPr/>
         </p:nvSpPr>
         <p:spPr>
           <a:xfrm>
-            <a:off x="594360" y="438912"/>
-            <a:ext cx="10881360" cy="1005840"/>
+            <a:off x="731520" y="1600200"/>
+            <a:ext cx="10698480" cy="960120"/>
           </a:xfrm>
           <a:prstGeom prst="rect">
             <a:avLst/>
@@ -3692,34 +3324,33 @@
           <a:noFill/>
         </p:spPr>
         <p:txBody>
-          <a:bodyPr wrap="none">
+          <a:bodyPr wrap="square">
             <a:spAutoFit/>
           </a:bodyPr>
           <a:lstStyle/>
           <a:p>
-            <a:pPr algn="l">
-              <a:defRPr sz="3000" b="1">
+            <a:pPr algn="l"/>
+            <a:r>
+              <a:rPr sz="1700" b="0">
                 <a:solidFill>
                   <a:srgbClr val="FFFFFF"/>
                 </a:solidFill>
-              </a:defRPr>
-            </a:pPr>
-            <a:r>
-              <a:t>The Consolidation Move</a:t>
-            </a:r>
-          </a:p>
-        </p:txBody>
-      </p:sp>
-      <p:sp>
-        <p:nvSpPr>
-          <p:cNvPr id="4" name="TextBox 3"/>
+              </a:rPr>
+              <a:t>  GA date: 23 April 2026</a:t>
+            </a:r>
+          </a:p>
+        </p:txBody>
+      </p:sp>
+      <p:sp>
+        <p:nvSpPr>
+          <p:cNvPr id="5" name="TextBox 4"/>
           <p:cNvSpPr txBox="1"/>
           <p:nvPr/>
         </p:nvSpPr>
         <p:spPr>
           <a:xfrm>
-            <a:off x="621792" y="1353312"/>
-            <a:ext cx="10607040" cy="411480"/>
+            <a:off x="731520" y="2651760"/>
+            <a:ext cx="10698480" cy="960120"/>
           </a:xfrm>
           <a:prstGeom prst="rect">
             <a:avLst/>
@@ -3727,34 +3358,33 @@
           <a:noFill/>
         </p:spPr>
         <p:txBody>
-          <a:bodyPr wrap="none">
+          <a:bodyPr wrap="square">
             <a:spAutoFit/>
           </a:bodyPr>
           <a:lstStyle/>
           <a:p>
-            <a:pPr>
-              <a:defRPr sz="1400">
-                <a:solidFill>
-                  <a:srgbClr val="D4D4D8"/>
-                </a:solidFill>
-              </a:defRPr>
-            </a:pPr>
-            <a:r>
-              <a:t>Why this platform matters</a:t>
-            </a:r>
-          </a:p>
-        </p:txBody>
-      </p:sp>
-      <p:sp>
-        <p:nvSpPr>
-          <p:cNvPr id="5" name="TextBox 4"/>
+            <a:pPr algn="l"/>
+            <a:r>
+              <a:rPr sz="1700" b="0">
+                <a:solidFill>
+                  <a:srgbClr val="FFFFFF"/>
+                </a:solidFill>
+              </a:rPr>
+              <a:t>  Replaces and absorbs: Vertex AI Agent Builder, Model Garden (as a sub-surface), Dialogflow CX (legacy path)</a:t>
+            </a:r>
+          </a:p>
+        </p:txBody>
+      </p:sp>
+      <p:sp>
+        <p:nvSpPr>
+          <p:cNvPr id="6" name="TextBox 5"/>
           <p:cNvSpPr txBox="1"/>
           <p:nvPr/>
         </p:nvSpPr>
         <p:spPr>
           <a:xfrm>
-            <a:off x="804672" y="1965960"/>
-            <a:ext cx="10652760" cy="4069080"/>
+            <a:off x="731520" y="3703320"/>
+            <a:ext cx="10698480" cy="960120"/>
           </a:xfrm>
           <a:prstGeom prst="rect">
             <a:avLst/>
@@ -3767,93 +3397,28 @@
           </a:bodyPr>
           <a:lstStyle/>
           <a:p>
-            <a:pPr marL="0">
-              <a:lnSpc>
-                <a:spcPct val="108000"/>
-              </a:lnSpc>
-              <a:spcAft>
-                <a:spcPts val="1100"/>
-              </a:spcAft>
-              <a:defRPr sz="1900">
+            <a:pPr algn="l"/>
+            <a:r>
+              <a:rPr sz="1700" b="0">
                 <a:solidFill>
                   <a:srgbClr val="FFFFFF"/>
                 </a:solidFill>
-                <a:latin typeface="Aptos"/>
-              </a:defRPr>
-            </a:pPr>
-            <a:r>
-              <a:t>GEAP absorbs Vertex AI Agent Builder, Model Garden, and Dialogflow CX paths under one agent platform story</a:t>
-            </a:r>
-          </a:p>
-          <a:p>
-            <a:pPr marL="0">
-              <a:lnSpc>
-                <a:spcPct val="108000"/>
-              </a:lnSpc>
-              <a:spcAft>
-                <a:spcPts val="1100"/>
-              </a:spcAft>
-              <a:defRPr sz="1900">
-                <a:solidFill>
-                  <a:srgbClr val="D4D4D8"/>
-                </a:solidFill>
-                <a:latin typeface="Aptos"/>
-              </a:defRPr>
-            </a:pPr>
-            <a:r>
-              <a:t>Google's strategic signal: future Vertex AI roadmap evolutions flow through Agent Platform rather than standalone services</a:t>
-            </a:r>
-          </a:p>
-          <a:p>
-            <a:pPr marL="0">
-              <a:lnSpc>
-                <a:spcPct val="108000"/>
-              </a:lnSpc>
-              <a:spcAft>
-                <a:spcPts val="1100"/>
-              </a:spcAft>
-              <a:defRPr sz="1900">
-                <a:solidFill>
-                  <a:srgbClr val="D4D4D8"/>
-                </a:solidFill>
-                <a:latin typeface="Aptos"/>
-              </a:defRPr>
-            </a:pPr>
-            <a:r>
-              <a:t>The useful question is whether your use case needs the platform layer, not whether Google has many AI products</a:t>
-            </a:r>
-          </a:p>
-          <a:p>
-            <a:pPr marL="0">
-              <a:lnSpc>
-                <a:spcPct val="108000"/>
-              </a:lnSpc>
-              <a:spcAft>
-                <a:spcPts val="1100"/>
-              </a:spcAft>
-              <a:defRPr sz="1900">
-                <a:solidFill>
-                  <a:srgbClr val="D4D4D8"/>
-                </a:solidFill>
-                <a:latin typeface="Aptos"/>
-              </a:defRPr>
-            </a:pPr>
-            <a:r>
-              <a:t>GEAP is runtime, identity, gateway, memory, registry, and observability around agents</a:t>
-            </a:r>
-          </a:p>
-        </p:txBody>
-      </p:sp>
-      <p:sp>
-        <p:nvSpPr>
-          <p:cNvPr id="6" name="TextBox 5"/>
+              </a:rPr>
+              <a:t>  Architecture: four pillars — Build, Scale, Govern, Optimize</a:t>
+            </a:r>
+          </a:p>
+        </p:txBody>
+      </p:sp>
+      <p:sp>
+        <p:nvSpPr>
+          <p:cNvPr id="7" name="TextBox 6"/>
           <p:cNvSpPr txBox="1"/>
           <p:nvPr/>
         </p:nvSpPr>
         <p:spPr>
           <a:xfrm>
-            <a:off x="502920" y="6446520"/>
-            <a:ext cx="11201400" cy="228600"/>
+            <a:off x="731520" y="4754880"/>
+            <a:ext cx="10698480" cy="960120"/>
           </a:xfrm>
           <a:prstGeom prst="rect">
             <a:avLst/>
@@ -3861,20 +3426,53 @@
           <a:noFill/>
         </p:spPr>
         <p:txBody>
-          <a:bodyPr wrap="none">
+          <a:bodyPr wrap="square">
             <a:spAutoFit/>
           </a:bodyPr>
           <a:lstStyle/>
           <a:p>
-            <a:pPr algn="r">
-              <a:defRPr sz="800">
+            <a:pPr algn="l"/>
+            <a:r>
+              <a:rPr sz="1700" b="0">
+                <a:solidFill>
+                  <a:srgbClr val="FFFFFF"/>
+                </a:solidFill>
+              </a:rPr>
+              <a:t>  Model access: 200+ models including Gemini 3.1 Pro/Flash, Gemma 4, Anthropic Claude (Opus/Sonnet/Haiku), and third-party</a:t>
+            </a:r>
+          </a:p>
+        </p:txBody>
+      </p:sp>
+      <p:sp>
+        <p:nvSpPr>
+          <p:cNvPr id="8" name="TextBox 7"/>
+          <p:cNvSpPr txBox="1"/>
+          <p:nvPr/>
+        </p:nvSpPr>
+        <p:spPr>
+          <a:xfrm>
+            <a:off x="731520" y="6263640"/>
+            <a:ext cx="10698480" cy="365760"/>
+          </a:xfrm>
+          <a:prstGeom prst="rect">
+            <a:avLst/>
+          </a:prstGeom>
+          <a:noFill/>
+        </p:spPr>
+        <p:txBody>
+          <a:bodyPr wrap="square">
+            <a:spAutoFit/>
+          </a:bodyPr>
+          <a:lstStyle/>
+          <a:p>
+            <a:pPr algn="l"/>
+            <a:r>
+              <a:rPr sz="1000" b="0">
                 <a:solidFill>
                   <a:srgbClr val="A1A1AA"/>
                 </a:solidFill>
-              </a:defRPr>
-            </a:pPr>
-            <a:r>
-              <a:t>academy.kspl.tech | Koenig AI Academy · 02</a:t>
+              </a:rPr>
+              <a:t>academy.kspl.tech | Koenig AI Academy</a:t>
             </a:r>
           </a:p>
         </p:txBody>
@@ -3907,20 +3505,54 @@
       <p:grpSpPr/>
       <p:sp>
         <p:nvSpPr>
-          <p:cNvPr id="2" name="Rectangle 1"/>
+          <p:cNvPr id="2" name="TextBox 1"/>
+          <p:cNvSpPr txBox="1"/>
+          <p:nvPr/>
+        </p:nvSpPr>
+        <p:spPr>
+          <a:xfrm>
+            <a:off x="731520" y="411480"/>
+            <a:ext cx="10698480" cy="1005840"/>
+          </a:xfrm>
+          <a:prstGeom prst="rect">
+            <a:avLst/>
+          </a:prstGeom>
+          <a:noFill/>
+        </p:spPr>
+        <p:txBody>
+          <a:bodyPr wrap="square">
+            <a:spAutoFit/>
+          </a:bodyPr>
+          <a:lstStyle/>
+          <a:p>
+            <a:pPr algn="l"/>
+            <a:r>
+              <a:rPr sz="2800" b="1">
+                <a:solidFill>
+                  <a:srgbClr val="FFFFFF"/>
+                </a:solidFill>
+              </a:rPr>
+              <a:t>The consolidation nobody saw coming</a:t>
+            </a:r>
+          </a:p>
+        </p:txBody>
+      </p:sp>
+      <p:sp>
+        <p:nvSpPr>
+          <p:cNvPr id="3" name="Rectangle 2"/>
           <p:cNvSpPr/>
           <p:nvPr/>
         </p:nvSpPr>
         <p:spPr>
           <a:xfrm>
-            <a:off x="0" y="0"/>
-            <a:ext cx="109728" cy="6858000"/>
+            <a:off x="731520" y="1417320"/>
+            <a:ext cx="10698480" cy="36576"/>
           </a:xfrm>
           <a:prstGeom prst="rect">
             <a:avLst/>
           </a:prstGeom>
           <a:solidFill>
-            <a:srgbClr val="FBBF24"/>
+            <a:srgbClr val="A1A1AA"/>
           </a:solidFill>
           <a:ln>
             <a:noFill/>
@@ -3950,14 +3582,14 @@
       </p:sp>
       <p:sp>
         <p:nvSpPr>
-          <p:cNvPr id="3" name="TextBox 2"/>
+          <p:cNvPr id="4" name="TextBox 3"/>
           <p:cNvSpPr txBox="1"/>
           <p:nvPr/>
         </p:nvSpPr>
         <p:spPr>
           <a:xfrm>
-            <a:off x="594360" y="438912"/>
-            <a:ext cx="10881360" cy="1005840"/>
+            <a:off x="731520" y="1600200"/>
+            <a:ext cx="10698480" cy="960120"/>
           </a:xfrm>
           <a:prstGeom prst="rect">
             <a:avLst/>
@@ -3965,34 +3597,33 @@
           <a:noFill/>
         </p:spPr>
         <p:txBody>
-          <a:bodyPr wrap="none">
+          <a:bodyPr wrap="square">
             <a:spAutoFit/>
           </a:bodyPr>
           <a:lstStyle/>
           <a:p>
-            <a:pPr algn="l">
-              <a:defRPr sz="3000" b="1">
+            <a:pPr algn="l"/>
+            <a:r>
+              <a:rPr sz="1700" b="0">
                 <a:solidFill>
                   <a:srgbClr val="FFFFFF"/>
                 </a:solidFill>
-              </a:defRPr>
-            </a:pPr>
-            <a:r>
-              <a:t>Keep Model Surfaces Separate</a:t>
-            </a:r>
-          </a:p>
-        </p:txBody>
-      </p:sp>
-      <p:sp>
-        <p:nvSpPr>
-          <p:cNvPr id="4" name="TextBox 3"/>
+              </a:rPr>
+              <a:t>  When Google announced GEAP, industry coverage focused on the new features: sub-agent networks, Memory Bank, Agent Identi</a:t>
+            </a:r>
+          </a:p>
+        </p:txBody>
+      </p:sp>
+      <p:sp>
+        <p:nvSpPr>
+          <p:cNvPr id="5" name="TextBox 4"/>
           <p:cNvSpPr txBox="1"/>
           <p:nvPr/>
         </p:nvSpPr>
         <p:spPr>
           <a:xfrm>
-            <a:off x="621792" y="1353312"/>
-            <a:ext cx="10607040" cy="411480"/>
+            <a:off x="731520" y="2651760"/>
+            <a:ext cx="10698480" cy="960120"/>
           </a:xfrm>
           <a:prstGeom prst="rect">
             <a:avLst/>
@@ -4000,34 +3631,33 @@
           <a:noFill/>
         </p:spPr>
         <p:txBody>
-          <a:bodyPr wrap="none">
+          <a:bodyPr wrap="square">
             <a:spAutoFit/>
           </a:bodyPr>
           <a:lstStyle/>
           <a:p>
-            <a:pPr>
-              <a:defRPr sz="1400">
-                <a:solidFill>
-                  <a:srgbClr val="D4D4D8"/>
-                </a:solidFill>
-              </a:defRPr>
-            </a:pPr>
-            <a:r>
-              <a:t>Gemini access is not the same thing as the agent platform</a:t>
-            </a:r>
-          </a:p>
-        </p:txBody>
-      </p:sp>
-      <p:sp>
-        <p:nvSpPr>
-          <p:cNvPr id="5" name="TextBox 4"/>
+            <a:pPr algn="l"/>
+            <a:r>
+              <a:rPr sz="1700" b="0">
+                <a:solidFill>
+                  <a:srgbClr val="FFFFFF"/>
+                </a:solidFill>
+              </a:rPr>
+              <a:t>  That is a major commitment. It means if you are using Vertex AI Pipelines, Vertex AI Evaluation, or any other standalone</a:t>
+            </a:r>
+          </a:p>
+        </p:txBody>
+      </p:sp>
+      <p:sp>
+        <p:nvSpPr>
+          <p:cNvPr id="6" name="TextBox 5"/>
           <p:cNvSpPr txBox="1"/>
           <p:nvPr/>
         </p:nvSpPr>
         <p:spPr>
           <a:xfrm>
-            <a:off x="804672" y="1965960"/>
-            <a:ext cx="10652760" cy="4069080"/>
+            <a:off x="731520" y="3703320"/>
+            <a:ext cx="10698480" cy="960120"/>
           </a:xfrm>
           <a:prstGeom prst="rect">
             <a:avLst/>
@@ -4040,93 +3670,28 @@
           </a:bodyPr>
           <a:lstStyle/>
           <a:p>
-            <a:pPr marL="0">
-              <a:lnSpc>
-                <a:spcPct val="108000"/>
-              </a:lnSpc>
-              <a:spcAft>
-                <a:spcPts val="1100"/>
-              </a:spcAft>
-              <a:defRPr sz="1900">
+            <a:pPr algn="l"/>
+            <a:r>
+              <a:rPr sz="1700" b="0">
                 <a:solidFill>
                   <a:srgbClr val="FFFFFF"/>
                 </a:solidFill>
-                <a:latin typeface="Aptos"/>
-              </a:defRPr>
-            </a:pPr>
-            <a:r>
-              <a:t>Gemini API and AI Studio are developer prototyping surfaces</a:t>
-            </a:r>
-          </a:p>
-          <a:p>
-            <a:pPr marL="0">
-              <a:lnSpc>
-                <a:spcPct val="108000"/>
-              </a:lnSpc>
-              <a:spcAft>
-                <a:spcPts val="1100"/>
-              </a:spcAft>
-              <a:defRPr sz="1900">
-                <a:solidFill>
-                  <a:srgbClr val="D4D4D8"/>
-                </a:solidFill>
-                <a:latin typeface="Aptos"/>
-              </a:defRPr>
-            </a:pPr>
-            <a:r>
-              <a:t>Vertex AI and Gemini Enterprise are managed enterprise deployment surfaces</a:t>
-            </a:r>
-          </a:p>
-          <a:p>
-            <a:pPr marL="0">
-              <a:lnSpc>
-                <a:spcPct val="108000"/>
-              </a:lnSpc>
-              <a:spcAft>
-                <a:spcPts val="1100"/>
-              </a:spcAft>
-              <a:defRPr sz="1900">
-                <a:solidFill>
-                  <a:srgbClr val="D4D4D8"/>
-                </a:solidFill>
-                <a:latin typeface="Aptos"/>
-              </a:defRPr>
-            </a:pPr>
-            <a:r>
-              <a:t>NotebookLM and Gemini notebooks are source-grounded knowledge-work surfaces</a:t>
-            </a:r>
-          </a:p>
-          <a:p>
-            <a:pPr marL="0">
-              <a:lnSpc>
-                <a:spcPct val="108000"/>
-              </a:lnSpc>
-              <a:spcAft>
-                <a:spcPts val="1100"/>
-              </a:spcAft>
-              <a:defRPr sz="1900">
-                <a:solidFill>
-                  <a:srgbClr val="D4D4D8"/>
-                </a:solidFill>
-                <a:latin typeface="Aptos"/>
-              </a:defRPr>
-            </a:pPr>
-            <a:r>
-              <a:t>GEAP is the production agent layer with quotas, launch stages, and limits distinct from model previews</a:t>
-            </a:r>
-          </a:p>
-        </p:txBody>
-      </p:sp>
-      <p:sp>
-        <p:nvSpPr>
-          <p:cNvPr id="6" name="TextBox 5"/>
+              </a:rPr>
+              <a:t>  Model Surfaces vs. Agent Platform: Google's frontier models (like Gemini 3.1 Pro) appear in multiple "surfaces" simultan</a:t>
+            </a:r>
+          </a:p>
+        </p:txBody>
+      </p:sp>
+      <p:sp>
+        <p:nvSpPr>
+          <p:cNvPr id="7" name="TextBox 6"/>
           <p:cNvSpPr txBox="1"/>
           <p:nvPr/>
         </p:nvSpPr>
         <p:spPr>
           <a:xfrm>
-            <a:off x="502920" y="6446520"/>
-            <a:ext cx="11201400" cy="228600"/>
+            <a:off x="731520" y="4754880"/>
+            <a:ext cx="10698480" cy="960120"/>
           </a:xfrm>
           <a:prstGeom prst="rect">
             <a:avLst/>
@@ -4134,20 +3699,53 @@
           <a:noFill/>
         </p:spPr>
         <p:txBody>
-          <a:bodyPr wrap="none">
+          <a:bodyPr wrap="square">
             <a:spAutoFit/>
           </a:bodyPr>
           <a:lstStyle/>
           <a:p>
-            <a:pPr algn="r">
-              <a:defRPr sz="800">
+            <a:pPr algn="l"/>
+            <a:r>
+              <a:rPr sz="1700" b="0">
+                <a:solidFill>
+                  <a:srgbClr val="FFFFFF"/>
+                </a:solidFill>
+              </a:rPr>
+              <a:t>  Whether that bet pays off for you depends on your use case. This chapter explains the architecture so you can make that </a:t>
+            </a:r>
+          </a:p>
+        </p:txBody>
+      </p:sp>
+      <p:sp>
+        <p:nvSpPr>
+          <p:cNvPr id="8" name="TextBox 7"/>
+          <p:cNvSpPr txBox="1"/>
+          <p:nvPr/>
+        </p:nvSpPr>
+        <p:spPr>
+          <a:xfrm>
+            <a:off x="731520" y="6263640"/>
+            <a:ext cx="10698480" cy="365760"/>
+          </a:xfrm>
+          <a:prstGeom prst="rect">
+            <a:avLst/>
+          </a:prstGeom>
+          <a:noFill/>
+        </p:spPr>
+        <p:txBody>
+          <a:bodyPr wrap="square">
+            <a:spAutoFit/>
+          </a:bodyPr>
+          <a:lstStyle/>
+          <a:p>
+            <a:pPr algn="l"/>
+            <a:r>
+              <a:rPr sz="1000" b="0">
                 <a:solidFill>
                   <a:srgbClr val="A1A1AA"/>
                 </a:solidFill>
-              </a:defRPr>
-            </a:pPr>
-            <a:r>
-              <a:t>academy.kspl.tech | Koenig AI Academy · 03</a:t>
+              </a:rPr>
+              <a:t>academy.kspl.tech | Koenig AI Academy</a:t>
             </a:r>
           </a:p>
         </p:txBody>
@@ -4180,20 +3778,54 @@
       <p:grpSpPr/>
       <p:sp>
         <p:nvSpPr>
-          <p:cNvPr id="2" name="Rectangle 1"/>
+          <p:cNvPr id="2" name="TextBox 1"/>
+          <p:cNvSpPr txBox="1"/>
+          <p:nvPr/>
+        </p:nvSpPr>
+        <p:spPr>
+          <a:xfrm>
+            <a:off x="731520" y="411480"/>
+            <a:ext cx="10698480" cy="1005840"/>
+          </a:xfrm>
+          <a:prstGeom prst="rect">
+            <a:avLst/>
+          </a:prstGeom>
+          <a:noFill/>
+        </p:spPr>
+        <p:txBody>
+          <a:bodyPr wrap="square">
+            <a:spAutoFit/>
+          </a:bodyPr>
+          <a:lstStyle/>
+          <a:p>
+            <a:pPr algn="l"/>
+            <a:r>
+              <a:rPr sz="2800" b="1">
+                <a:solidFill>
+                  <a:srgbClr val="FFFFFF"/>
+                </a:solidFill>
+              </a:rPr>
+              <a:t>The four pillars</a:t>
+            </a:r>
+          </a:p>
+        </p:txBody>
+      </p:sp>
+      <p:sp>
+        <p:nvSpPr>
+          <p:cNvPr id="3" name="Rectangle 2"/>
           <p:cNvSpPr/>
           <p:nvPr/>
         </p:nvSpPr>
         <p:spPr>
           <a:xfrm>
-            <a:off x="0" y="0"/>
-            <a:ext cx="109728" cy="6858000"/>
+            <a:off x="731520" y="1417320"/>
+            <a:ext cx="10698480" cy="36576"/>
           </a:xfrm>
           <a:prstGeom prst="rect">
             <a:avLst/>
           </a:prstGeom>
           <a:solidFill>
-            <a:srgbClr val="F87171"/>
+            <a:srgbClr val="A1A1AA"/>
           </a:solidFill>
           <a:ln>
             <a:noFill/>
@@ -4223,14 +3855,14 @@
       </p:sp>
       <p:sp>
         <p:nvSpPr>
-          <p:cNvPr id="3" name="TextBox 2"/>
+          <p:cNvPr id="4" name="TextBox 3"/>
           <p:cNvSpPr txBox="1"/>
           <p:nvPr/>
         </p:nvSpPr>
         <p:spPr>
           <a:xfrm>
-            <a:off x="594360" y="438912"/>
-            <a:ext cx="10881360" cy="1005840"/>
+            <a:off x="731520" y="1600200"/>
+            <a:ext cx="10698480" cy="960120"/>
           </a:xfrm>
           <a:prstGeom prst="rect">
             <a:avLst/>
@@ -4238,34 +3870,33 @@
           <a:noFill/>
         </p:spPr>
         <p:txBody>
-          <a:bodyPr wrap="none">
+          <a:bodyPr wrap="square">
             <a:spAutoFit/>
           </a:bodyPr>
           <a:lstStyle/>
           <a:p>
-            <a:pPr algn="l">
-              <a:defRPr sz="3000" b="1">
+            <a:pPr algn="l"/>
+            <a:r>
+              <a:rPr sz="1700" b="0">
                 <a:solidFill>
                   <a:srgbClr val="FFFFFF"/>
                 </a:solidFill>
-              </a:defRPr>
-            </a:pPr>
-            <a:r>
-              <a:t>Pillar 1: Build</a:t>
-            </a:r>
-          </a:p>
-        </p:txBody>
-      </p:sp>
-      <p:sp>
-        <p:nvSpPr>
-          <p:cNvPr id="4" name="TextBox 3"/>
+              </a:rPr>
+              <a:t>  GEAP is organized into four operational domains. Every feature belongs to one of them. Knowing which pillar a feature be</a:t>
+            </a:r>
+          </a:p>
+        </p:txBody>
+      </p:sp>
+      <p:sp>
+        <p:nvSpPr>
+          <p:cNvPr id="5" name="TextBox 4"/>
           <p:cNvSpPr txBox="1"/>
           <p:nvPr/>
         </p:nvSpPr>
         <p:spPr>
           <a:xfrm>
-            <a:off x="621792" y="1353312"/>
-            <a:ext cx="10607040" cy="411480"/>
+            <a:off x="731520" y="2651760"/>
+            <a:ext cx="10698480" cy="960120"/>
           </a:xfrm>
           <a:prstGeom prst="rect">
             <a:avLst/>
@@ -4273,34 +3904,33 @@
           <a:noFill/>
         </p:spPr>
         <p:txBody>
-          <a:bodyPr wrap="none">
+          <a:bodyPr wrap="square">
             <a:spAutoFit/>
           </a:bodyPr>
           <a:lstStyle/>
           <a:p>
-            <a:pPr>
-              <a:defRPr sz="1400">
-                <a:solidFill>
-                  <a:srgbClr val="D4D4D8"/>
-                </a:solidFill>
-              </a:defRPr>
-            </a:pPr>
-            <a:r>
-              <a:t>How agents get created</a:t>
-            </a:r>
-          </a:p>
-        </p:txBody>
-      </p:sp>
-      <p:sp>
-        <p:nvSpPr>
-          <p:cNvPr id="5" name="TextBox 4"/>
+            <a:pPr algn="l"/>
+            <a:r>
+              <a:rPr sz="1700" b="0">
+                <a:solidFill>
+                  <a:srgbClr val="FFFFFF"/>
+                </a:solidFill>
+              </a:rPr>
+              <a:t>  Pillar 1: Build</a:t>
+            </a:r>
+          </a:p>
+        </p:txBody>
+      </p:sp>
+      <p:sp>
+        <p:nvSpPr>
+          <p:cNvPr id="6" name="TextBox 5"/>
           <p:cNvSpPr txBox="1"/>
           <p:nvPr/>
         </p:nvSpPr>
         <p:spPr>
           <a:xfrm>
-            <a:off x="804672" y="1965960"/>
-            <a:ext cx="10652760" cy="4069080"/>
+            <a:off x="731520" y="3703320"/>
+            <a:ext cx="10698480" cy="960120"/>
           </a:xfrm>
           <a:prstGeom prst="rect">
             <a:avLst/>
@@ -4313,93 +3943,28 @@
           </a:bodyPr>
           <a:lstStyle/>
           <a:p>
-            <a:pPr marL="0">
-              <a:lnSpc>
-                <a:spcPct val="108000"/>
-              </a:lnSpc>
-              <a:spcAft>
-                <a:spcPts val="1100"/>
-              </a:spcAft>
-              <a:defRPr sz="1900">
+            <a:pPr algn="l"/>
+            <a:r>
+              <a:rPr sz="1700" b="0">
                 <a:solidFill>
                   <a:srgbClr val="FFFFFF"/>
                 </a:solidFill>
-                <a:latin typeface="Aptos"/>
-              </a:defRPr>
-            </a:pPr>
-            <a:r>
-              <a:t>Agent Studio provides low-code visual assembly for prototyping and guarded configuration</a:t>
-            </a:r>
-          </a:p>
-          <a:p>
-            <a:pPr marL="0">
-              <a:lnSpc>
-                <a:spcPct val="108000"/>
-              </a:lnSpc>
-              <a:spcAft>
-                <a:spcPts val="1100"/>
-              </a:spcAft>
-              <a:defRPr sz="1900">
-                <a:solidFill>
-                  <a:srgbClr val="D4D4D8"/>
-                </a:solidFill>
-                <a:latin typeface="Aptos"/>
-              </a:defRPr>
-            </a:pPr>
-            <a:r>
-              <a:t>Agent Development Kit is the code-first Python and TypeScript path used for production control</a:t>
-            </a:r>
-          </a:p>
-          <a:p>
-            <a:pPr marL="0">
-              <a:lnSpc>
-                <a:spcPct val="108000"/>
-              </a:lnSpc>
-              <a:spcAft>
-                <a:spcPts val="1100"/>
-              </a:spcAft>
-              <a:defRPr sz="1900">
-                <a:solidFill>
-                  <a:srgbClr val="D4D4D8"/>
-                </a:solidFill>
-                <a:latin typeface="Aptos"/>
-              </a:defRPr>
-            </a:pPr>
-            <a:r>
-              <a:t>Agent Garden offers templates for common enterprise tasks that still need customization</a:t>
-            </a:r>
-          </a:p>
-          <a:p>
-            <a:pPr marL="0">
-              <a:lnSpc>
-                <a:spcPct val="108000"/>
-              </a:lnSpc>
-              <a:spcAft>
-                <a:spcPts val="1100"/>
-              </a:spcAft>
-              <a:defRPr sz="1900">
-                <a:solidFill>
-                  <a:srgbClr val="D4D4D8"/>
-                </a:solidFill>
-                <a:latin typeface="Aptos"/>
-              </a:defRPr>
-            </a:pPr>
-            <a:r>
-              <a:t>Workspaces give agents hardened sandboxes for bash commands and file operations</a:t>
-            </a:r>
-          </a:p>
-        </p:txBody>
-      </p:sp>
-      <p:sp>
-        <p:nvSpPr>
-          <p:cNvPr id="6" name="TextBox 5"/>
+              </a:rPr>
+              <a:t>  Build is where you create agents. There are two entry points:</a:t>
+            </a:r>
+          </a:p>
+        </p:txBody>
+      </p:sp>
+      <p:sp>
+        <p:nvSpPr>
+          <p:cNvPr id="7" name="TextBox 6"/>
           <p:cNvSpPr txBox="1"/>
           <p:nvPr/>
         </p:nvSpPr>
         <p:spPr>
           <a:xfrm>
-            <a:off x="502920" y="6446520"/>
-            <a:ext cx="11201400" cy="228600"/>
+            <a:off x="731520" y="4754880"/>
+            <a:ext cx="10698480" cy="960120"/>
           </a:xfrm>
           <a:prstGeom prst="rect">
             <a:avLst/>
@@ -4407,20 +3972,53 @@
           <a:noFill/>
         </p:spPr>
         <p:txBody>
-          <a:bodyPr wrap="none">
+          <a:bodyPr wrap="square">
             <a:spAutoFit/>
           </a:bodyPr>
           <a:lstStyle/>
           <a:p>
-            <a:pPr algn="r">
-              <a:defRPr sz="800">
+            <a:pPr algn="l"/>
+            <a:r>
+              <a:rPr sz="1700" b="0">
+                <a:solidFill>
+                  <a:srgbClr val="FFFFFF"/>
+                </a:solidFill>
+              </a:rPr>
+              <a:t>  Agent Studio is a low-code, visual interface. You drag components, define tools from a catalogue, set an instruction pro</a:t>
+            </a:r>
+          </a:p>
+        </p:txBody>
+      </p:sp>
+      <p:sp>
+        <p:nvSpPr>
+          <p:cNvPr id="8" name="TextBox 7"/>
+          <p:cNvSpPr txBox="1"/>
+          <p:nvPr/>
+        </p:nvSpPr>
+        <p:spPr>
+          <a:xfrm>
+            <a:off x="731520" y="6263640"/>
+            <a:ext cx="10698480" cy="365760"/>
+          </a:xfrm>
+          <a:prstGeom prst="rect">
+            <a:avLst/>
+          </a:prstGeom>
+          <a:noFill/>
+        </p:spPr>
+        <p:txBody>
+          <a:bodyPr wrap="square">
+            <a:spAutoFit/>
+          </a:bodyPr>
+          <a:lstStyle/>
+          <a:p>
+            <a:pPr algn="l"/>
+            <a:r>
+              <a:rPr sz="1000" b="0">
                 <a:solidFill>
                   <a:srgbClr val="A1A1AA"/>
                 </a:solidFill>
-              </a:defRPr>
-            </a:pPr>
-            <a:r>
-              <a:t>academy.kspl.tech | Koenig AI Academy · 04</a:t>
+              </a:rPr>
+              <a:t>academy.kspl.tech | Koenig AI Academy</a:t>
             </a:r>
           </a:p>
         </p:txBody>
@@ -4453,20 +4051,54 @@
       <p:grpSpPr/>
       <p:sp>
         <p:nvSpPr>
-          <p:cNvPr id="2" name="Rectangle 1"/>
+          <p:cNvPr id="2" name="TextBox 1"/>
+          <p:cNvSpPr txBox="1"/>
+          <p:nvPr/>
+        </p:nvSpPr>
+        <p:spPr>
+          <a:xfrm>
+            <a:off x="731520" y="411480"/>
+            <a:ext cx="10698480" cy="1005840"/>
+          </a:xfrm>
+          <a:prstGeom prst="rect">
+            <a:avLst/>
+          </a:prstGeom>
+          <a:noFill/>
+        </p:spPr>
+        <p:txBody>
+          <a:bodyPr wrap="square">
+            <a:spAutoFit/>
+          </a:bodyPr>
+          <a:lstStyle/>
+          <a:p>
+            <a:pPr algn="l"/>
+            <a:r>
+              <a:rPr sz="2800" b="1">
+                <a:solidFill>
+                  <a:srgbClr val="FFFFFF"/>
+                </a:solidFill>
+              </a:rPr>
+              <a:t>What GEAP is not</a:t>
+            </a:r>
+          </a:p>
+        </p:txBody>
+      </p:sp>
+      <p:sp>
+        <p:nvSpPr>
+          <p:cNvPr id="3" name="Rectangle 2"/>
           <p:cNvSpPr/>
           <p:nvPr/>
         </p:nvSpPr>
         <p:spPr>
           <a:xfrm>
-            <a:off x="0" y="0"/>
-            <a:ext cx="109728" cy="6858000"/>
+            <a:off x="731520" y="1417320"/>
+            <a:ext cx="10698480" cy="36576"/>
           </a:xfrm>
           <a:prstGeom prst="rect">
             <a:avLst/>
           </a:prstGeom>
           <a:solidFill>
-            <a:srgbClr val="60A5FA"/>
+            <a:srgbClr val="A1A1AA"/>
           </a:solidFill>
           <a:ln>
             <a:noFill/>
@@ -4496,14 +4128,14 @@
       </p:sp>
       <p:sp>
         <p:nvSpPr>
-          <p:cNvPr id="3" name="TextBox 2"/>
+          <p:cNvPr id="4" name="TextBox 3"/>
           <p:cNvSpPr txBox="1"/>
           <p:nvPr/>
         </p:nvSpPr>
         <p:spPr>
           <a:xfrm>
-            <a:off x="594360" y="438912"/>
-            <a:ext cx="10881360" cy="1005840"/>
+            <a:off x="731520" y="1600200"/>
+            <a:ext cx="10698480" cy="960120"/>
           </a:xfrm>
           <a:prstGeom prst="rect">
             <a:avLst/>
@@ -4511,34 +4143,33 @@
           <a:noFill/>
         </p:spPr>
         <p:txBody>
-          <a:bodyPr wrap="none">
+          <a:bodyPr wrap="square">
             <a:spAutoFit/>
           </a:bodyPr>
           <a:lstStyle/>
           <a:p>
-            <a:pPr algn="l">
-              <a:defRPr sz="3000" b="1">
+            <a:pPr algn="l"/>
+            <a:r>
+              <a:rPr sz="1700" b="0">
                 <a:solidFill>
                   <a:srgbClr val="FFFFFF"/>
                 </a:solidFill>
-              </a:defRPr>
-            </a:pPr>
-            <a:r>
-              <a:t>Pillar 2: Scale</a:t>
-            </a:r>
-          </a:p>
-        </p:txBody>
-      </p:sp>
-      <p:sp>
-        <p:nvSpPr>
-          <p:cNvPr id="4" name="TextBox 3"/>
+              </a:rPr>
+              <a:t>  The four pillars are comprehensive enough that it is easy to assume GEAP is everything. Three things it is not:</a:t>
+            </a:r>
+          </a:p>
+        </p:txBody>
+      </p:sp>
+      <p:sp>
+        <p:nvSpPr>
+          <p:cNvPr id="5" name="TextBox 4"/>
           <p:cNvSpPr txBox="1"/>
           <p:nvPr/>
         </p:nvSpPr>
         <p:spPr>
           <a:xfrm>
-            <a:off x="621792" y="1353312"/>
-            <a:ext cx="10607040" cy="411480"/>
+            <a:off x="731520" y="2651760"/>
+            <a:ext cx="10698480" cy="960120"/>
           </a:xfrm>
           <a:prstGeom prst="rect">
             <a:avLst/>
@@ -4546,34 +4177,33 @@
           <a:noFill/>
         </p:spPr>
         <p:txBody>
-          <a:bodyPr wrap="none">
+          <a:bodyPr wrap="square">
             <a:spAutoFit/>
           </a:bodyPr>
           <a:lstStyle/>
           <a:p>
-            <a:pPr>
-              <a:defRPr sz="1400">
-                <a:solidFill>
-                  <a:srgbClr val="D4D4D8"/>
-                </a:solidFill>
-              </a:defRPr>
-            </a:pPr>
-            <a:r>
-              <a:t>How agents become production-grade</a:t>
-            </a:r>
-          </a:p>
-        </p:txBody>
-      </p:sp>
-      <p:sp>
-        <p:nvSpPr>
-          <p:cNvPr id="5" name="TextBox 4"/>
+            <a:pPr algn="l"/>
+            <a:r>
+              <a:rPr sz="1700" b="0">
+                <a:solidFill>
+                  <a:srgbClr val="FFFFFF"/>
+                </a:solidFill>
+              </a:rPr>
+              <a:t>  It is not model-agnostic in practice. GEAP supports 200+ models including Claude and open models. But the tightest integ</a:t>
+            </a:r>
+          </a:p>
+        </p:txBody>
+      </p:sp>
+      <p:sp>
+        <p:nvSpPr>
+          <p:cNvPr id="6" name="TextBox 5"/>
           <p:cNvSpPr txBox="1"/>
           <p:nvPr/>
         </p:nvSpPr>
         <p:spPr>
           <a:xfrm>
-            <a:off x="804672" y="1965960"/>
-            <a:ext cx="10652760" cy="4069080"/>
+            <a:off x="731520" y="3703320"/>
+            <a:ext cx="10698480" cy="960120"/>
           </a:xfrm>
           <a:prstGeom prst="rect">
             <a:avLst/>
@@ -4586,93 +4216,28 @@
           </a:bodyPr>
           <a:lstStyle/>
           <a:p>
-            <a:pPr marL="0">
-              <a:lnSpc>
-                <a:spcPct val="108000"/>
-              </a:lnSpc>
-              <a:spcAft>
-                <a:spcPts val="1100"/>
-              </a:spcAft>
-              <a:defRPr sz="1900">
+            <a:pPr algn="l"/>
+            <a:r>
+              <a:rPr sz="1700" b="0">
                 <a:solidFill>
                   <a:srgbClr val="FFFFFF"/>
                 </a:solidFill>
-                <a:latin typeface="Aptos"/>
-              </a:defRPr>
-            </a:pPr>
-            <a:r>
-              <a:t>Agent Runtime deploys ADK agents without rewriting the agent code</a:t>
-            </a:r>
-          </a:p>
-          <a:p>
-            <a:pPr marL="0">
-              <a:lnSpc>
-                <a:spcPct val="108000"/>
-              </a:lnSpc>
-              <a:spcAft>
-                <a:spcPts val="1100"/>
-              </a:spcAft>
-              <a:defRPr sz="1900">
-                <a:solidFill>
-                  <a:srgbClr val="D4D4D8"/>
-                </a:solidFill>
-                <a:latin typeface="Aptos"/>
-              </a:defRPr>
-            </a:pPr>
-            <a:r>
-              <a:t>Agent Sessions store conversation-scoped state tied to an external session ID</a:t>
-            </a:r>
-          </a:p>
-          <a:p>
-            <a:pPr marL="0">
-              <a:lnSpc>
-                <a:spcPct val="108000"/>
-              </a:lnSpc>
-              <a:spcAft>
-                <a:spcPts val="1100"/>
-              </a:spcAft>
-              <a:defRPr sz="1900">
-                <a:solidFill>
-                  <a:srgbClr val="D4D4D8"/>
-                </a:solidFill>
-                <a:latin typeface="Aptos"/>
-              </a:defRPr>
-            </a:pPr>
-            <a:r>
-              <a:t>Memory Bank distills long-term, cross-session memory into retrievable profiles</a:t>
-            </a:r>
-          </a:p>
-          <a:p>
-            <a:pPr marL="0">
-              <a:lnSpc>
-                <a:spcPct val="108000"/>
-              </a:lnSpc>
-              <a:spcAft>
-                <a:spcPts val="1100"/>
-              </a:spcAft>
-              <a:defRPr sz="1900">
-                <a:solidFill>
-                  <a:srgbClr val="D4D4D8"/>
-                </a:solidFill>
-                <a:latin typeface="Aptos"/>
-              </a:defRPr>
-            </a:pPr>
-            <a:r>
-              <a:t>Agent-to-agent orchestration can be deterministic or generative depending on routing needs</a:t>
-            </a:r>
-          </a:p>
-        </p:txBody>
-      </p:sp>
-      <p:sp>
-        <p:nvSpPr>
-          <p:cNvPr id="6" name="TextBox 5"/>
+              </a:rPr>
+              <a:t>  It is not open-source. The ADK is open-source (Apache 2.0). The runtime, Memory Bank, Agent Gateway, and Govern features</a:t>
+            </a:r>
+          </a:p>
+        </p:txBody>
+      </p:sp>
+      <p:sp>
+        <p:nvSpPr>
+          <p:cNvPr id="7" name="TextBox 6"/>
           <p:cNvSpPr txBox="1"/>
           <p:nvPr/>
         </p:nvSpPr>
         <p:spPr>
           <a:xfrm>
-            <a:off x="502920" y="6446520"/>
-            <a:ext cx="11201400" cy="228600"/>
+            <a:off x="731520" y="4754880"/>
+            <a:ext cx="10698480" cy="960120"/>
           </a:xfrm>
           <a:prstGeom prst="rect">
             <a:avLst/>
@@ -4680,20 +4245,53 @@
           <a:noFill/>
         </p:spPr>
         <p:txBody>
-          <a:bodyPr wrap="none">
+          <a:bodyPr wrap="square">
             <a:spAutoFit/>
           </a:bodyPr>
           <a:lstStyle/>
           <a:p>
-            <a:pPr algn="r">
-              <a:defRPr sz="800">
+            <a:pPr algn="l"/>
+            <a:r>
+              <a:rPr sz="1700" b="0">
+                <a:solidFill>
+                  <a:srgbClr val="FFFFFF"/>
+                </a:solidFill>
+              </a:rPr>
+              <a:t>  It is not Dialogflow CX rebranded. Dialogflow CX was a flow-based, deterministic dialogue manager. GEAP's agents reason </a:t>
+            </a:r>
+          </a:p>
+        </p:txBody>
+      </p:sp>
+      <p:sp>
+        <p:nvSpPr>
+          <p:cNvPr id="8" name="TextBox 7"/>
+          <p:cNvSpPr txBox="1"/>
+          <p:nvPr/>
+        </p:nvSpPr>
+        <p:spPr>
+          <a:xfrm>
+            <a:off x="731520" y="6263640"/>
+            <a:ext cx="10698480" cy="365760"/>
+          </a:xfrm>
+          <a:prstGeom prst="rect">
+            <a:avLst/>
+          </a:prstGeom>
+          <a:noFill/>
+        </p:spPr>
+        <p:txBody>
+          <a:bodyPr wrap="square">
+            <a:spAutoFit/>
+          </a:bodyPr>
+          <a:lstStyle/>
+          <a:p>
+            <a:pPr algn="l"/>
+            <a:r>
+              <a:rPr sz="1000" b="0">
                 <a:solidFill>
                   <a:srgbClr val="A1A1AA"/>
                 </a:solidFill>
-              </a:defRPr>
-            </a:pPr>
-            <a:r>
-              <a:t>academy.kspl.tech | Koenig AI Academy · 05</a:t>
+              </a:rPr>
+              <a:t>academy.kspl.tech | Koenig AI Academy</a:t>
             </a:r>
           </a:p>
         </p:txBody>
@@ -4726,20 +4324,54 @@
       <p:grpSpPr/>
       <p:sp>
         <p:nvSpPr>
-          <p:cNvPr id="2" name="Rectangle 1"/>
+          <p:cNvPr id="2" name="TextBox 1"/>
+          <p:cNvSpPr txBox="1"/>
+          <p:nvPr/>
+        </p:nvSpPr>
+        <p:spPr>
+          <a:xfrm>
+            <a:off x="731520" y="411480"/>
+            <a:ext cx="10698480" cy="1005840"/>
+          </a:xfrm>
+          <a:prstGeom prst="rect">
+            <a:avLst/>
+          </a:prstGeom>
+          <a:noFill/>
+        </p:spPr>
+        <p:txBody>
+          <a:bodyPr wrap="square">
+            <a:spAutoFit/>
+          </a:bodyPr>
+          <a:lstStyle/>
+          <a:p>
+            <a:pPr algn="l"/>
+            <a:r>
+              <a:rPr sz="2800" b="1">
+                <a:solidFill>
+                  <a:srgbClr val="FFFFFF"/>
+                </a:solidFill>
+              </a:rPr>
+              <a:t>How the components connect</a:t>
+            </a:r>
+          </a:p>
+        </p:txBody>
+      </p:sp>
+      <p:sp>
+        <p:nvSpPr>
+          <p:cNvPr id="3" name="Rectangle 2"/>
           <p:cNvSpPr/>
           <p:nvPr/>
         </p:nvSpPr>
         <p:spPr>
           <a:xfrm>
-            <a:off x="0" y="0"/>
-            <a:ext cx="109728" cy="6858000"/>
+            <a:off x="731520" y="1417320"/>
+            <a:ext cx="10698480" cy="36576"/>
           </a:xfrm>
           <a:prstGeom prst="rect">
             <a:avLst/>
           </a:prstGeom>
           <a:solidFill>
-            <a:srgbClr val="34D399"/>
+            <a:srgbClr val="A1A1AA"/>
           </a:solidFill>
           <a:ln>
             <a:noFill/>
@@ -4769,14 +4401,14 @@
       </p:sp>
       <p:sp>
         <p:nvSpPr>
-          <p:cNvPr id="3" name="TextBox 2"/>
+          <p:cNvPr id="4" name="TextBox 3"/>
           <p:cNvSpPr txBox="1"/>
           <p:nvPr/>
         </p:nvSpPr>
         <p:spPr>
           <a:xfrm>
-            <a:off x="594360" y="438912"/>
-            <a:ext cx="10881360" cy="1005840"/>
+            <a:off x="731520" y="1600200"/>
+            <a:ext cx="10698480" cy="960120"/>
           </a:xfrm>
           <a:prstGeom prst="rect">
             <a:avLst/>
@@ -4784,34 +4416,33 @@
           <a:noFill/>
         </p:spPr>
         <p:txBody>
-          <a:bodyPr wrap="none">
+          <a:bodyPr wrap="square">
             <a:spAutoFit/>
           </a:bodyPr>
           <a:lstStyle/>
           <a:p>
-            <a:pPr algn="l">
-              <a:defRPr sz="3000" b="1">
+            <a:pPr algn="l"/>
+            <a:r>
+              <a:rPr sz="1700" b="0">
                 <a:solidFill>
                   <a:srgbClr val="FFFFFF"/>
                 </a:solidFill>
-              </a:defRPr>
-            </a:pPr>
-            <a:r>
-              <a:t>Pillar 3: Govern</a:t>
-            </a:r>
-          </a:p>
-        </p:txBody>
-      </p:sp>
-      <p:sp>
-        <p:nvSpPr>
-          <p:cNvPr id="4" name="TextBox 3"/>
+              </a:rPr>
+              <a:t>  Here is the component map for a typical customer-support agent on GEAP. Read this as a data-flow diagram, left to right:</a:t>
+            </a:r>
+          </a:p>
+        </p:txBody>
+      </p:sp>
+      <p:sp>
+        <p:nvSpPr>
+          <p:cNvPr id="5" name="TextBox 4"/>
           <p:cNvSpPr txBox="1"/>
           <p:nvPr/>
         </p:nvSpPr>
         <p:spPr>
           <a:xfrm>
-            <a:off x="621792" y="1353312"/>
-            <a:ext cx="10607040" cy="411480"/>
+            <a:off x="731520" y="2651760"/>
+            <a:ext cx="10698480" cy="960120"/>
           </a:xfrm>
           <a:prstGeom prst="rect">
             <a:avLst/>
@@ -4819,34 +4450,33 @@
           <a:noFill/>
         </p:spPr>
         <p:txBody>
-          <a:bodyPr wrap="none">
+          <a:bodyPr wrap="square">
             <a:spAutoFit/>
           </a:bodyPr>
           <a:lstStyle/>
           <a:p>
-            <a:pPr>
-              <a:defRPr sz="1400">
-                <a:solidFill>
-                  <a:srgbClr val="D4D4D8"/>
-                </a:solidFill>
-              </a:defRPr>
-            </a:pPr>
-            <a:r>
-              <a:t>How teams keep control</a:t>
-            </a:r>
-          </a:p>
-        </p:txBody>
-      </p:sp>
-      <p:sp>
-        <p:nvSpPr>
-          <p:cNvPr id="5" name="TextBox 4"/>
+            <a:pPr algn="l"/>
+            <a:r>
+              <a:rPr sz="1700" b="0">
+                <a:solidFill>
+                  <a:srgbClr val="FFFFFF"/>
+                </a:solidFill>
+              </a:rPr>
+              <a:t>  Agent Gateway  ◄── Model Armor (prompt injection filter)</a:t>
+            </a:r>
+          </a:p>
+        </p:txBody>
+      </p:sp>
+      <p:sp>
+        <p:nvSpPr>
+          <p:cNvPr id="6" name="TextBox 5"/>
           <p:cNvSpPr txBox="1"/>
           <p:nvPr/>
         </p:nvSpPr>
         <p:spPr>
           <a:xfrm>
-            <a:off x="804672" y="1965960"/>
-            <a:ext cx="10652760" cy="4069080"/>
+            <a:off x="731520" y="3703320"/>
+            <a:ext cx="10698480" cy="960120"/>
           </a:xfrm>
           <a:prstGeom prst="rect">
             <a:avLst/>
@@ -4859,93 +4489,28 @@
           </a:bodyPr>
           <a:lstStyle/>
           <a:p>
-            <a:pPr marL="0">
-              <a:lnSpc>
-                <a:spcPct val="108000"/>
-              </a:lnSpc>
-              <a:spcAft>
-                <a:spcPts val="1100"/>
-              </a:spcAft>
-              <a:defRPr sz="1900">
+            <a:pPr algn="l"/>
+            <a:r>
+              <a:rPr sz="1700" b="0">
                 <a:solidFill>
                   <a:srgbClr val="FFFFFF"/>
                 </a:solidFill>
-                <a:latin typeface="Aptos"/>
-              </a:defRPr>
-            </a:pPr>
-            <a:r>
-              <a:t>Agent Identity gives each deployed agent a cryptographic ID for auditable actions</a:t>
-            </a:r>
-          </a:p>
-          <a:p>
-            <a:pPr marL="0">
-              <a:lnSpc>
-                <a:spcPct val="108000"/>
-              </a:lnSpc>
-              <a:spcAft>
-                <a:spcPts val="1100"/>
-              </a:spcAft>
-              <a:defRPr sz="1900">
-                <a:solidFill>
-                  <a:srgbClr val="D4D4D8"/>
-                </a:solidFill>
-                <a:latin typeface="Aptos"/>
-              </a:defRPr>
-            </a:pPr>
-            <a:r>
-              <a:t>Agent Registry centralizes approved tools, agents, and reusable capability definitions</a:t>
-            </a:r>
-          </a:p>
-          <a:p>
-            <a:pPr marL="0">
-              <a:lnSpc>
-                <a:spcPct val="108000"/>
-              </a:lnSpc>
-              <a:spcAft>
-                <a:spcPts val="1100"/>
-              </a:spcAft>
-              <a:defRPr sz="1900">
-                <a:solidFill>
-                  <a:srgbClr val="D4D4D8"/>
-                </a:solidFill>
-                <a:latin typeface="Aptos"/>
-              </a:defRPr>
-            </a:pPr>
-            <a:r>
-              <a:t>Agent Gateway applies security policies, rate limits, and Model Armor protections to traffic</a:t>
-            </a:r>
-          </a:p>
-          <a:p>
-            <a:pPr marL="0">
-              <a:lnSpc>
-                <a:spcPct val="108000"/>
-              </a:lnSpc>
-              <a:spcAft>
-                <a:spcPts val="1100"/>
-              </a:spcAft>
-              <a:defRPr sz="1900">
-                <a:solidFill>
-                  <a:srgbClr val="D4D4D8"/>
-                </a:solidFill>
-                <a:latin typeface="Aptos"/>
-              </a:defRPr>
-            </a:pPr>
-            <a:r>
-              <a:t>Security Dashboard integrates with Security Command Center for vulnerability and asset visibility</a:t>
-            </a:r>
-          </a:p>
-        </p:txBody>
-      </p:sp>
-      <p:sp>
-        <p:nvSpPr>
-          <p:cNvPr id="6" name="TextBox 5"/>
+              </a:rPr>
+              <a:t>  Agent Runtime  ── resolves Agent Identity (cryptographic ID)</a:t>
+            </a:r>
+          </a:p>
+        </p:txBody>
+      </p:sp>
+      <p:sp>
+        <p:nvSpPr>
+          <p:cNvPr id="7" name="TextBox 6"/>
           <p:cNvSpPr txBox="1"/>
           <p:nvPr/>
         </p:nvSpPr>
         <p:spPr>
           <a:xfrm>
-            <a:off x="502920" y="6446520"/>
-            <a:ext cx="11201400" cy="228600"/>
+            <a:off x="731520" y="4754880"/>
+            <a:ext cx="10698480" cy="960120"/>
           </a:xfrm>
           <a:prstGeom prst="rect">
             <a:avLst/>
@@ -4953,20 +4518,53 @@
           <a:noFill/>
         </p:spPr>
         <p:txBody>
-          <a:bodyPr wrap="none">
+          <a:bodyPr wrap="square">
             <a:spAutoFit/>
           </a:bodyPr>
           <a:lstStyle/>
           <a:p>
-            <a:pPr algn="r">
-              <a:defRPr sz="800">
+            <a:pPr algn="l"/>
+            <a:r>
+              <a:rPr sz="1700" b="0">
+                <a:solidFill>
+                  <a:srgbClr val="FFFFFF"/>
+                </a:solidFill>
+              </a:rPr>
+              <a:t>  ├── loads Memory Bank profile (cross-session context)</a:t>
+            </a:r>
+          </a:p>
+        </p:txBody>
+      </p:sp>
+      <p:sp>
+        <p:nvSpPr>
+          <p:cNvPr id="8" name="TextBox 7"/>
+          <p:cNvSpPr txBox="1"/>
+          <p:nvPr/>
+        </p:nvSpPr>
+        <p:spPr>
+          <a:xfrm>
+            <a:off x="731520" y="6263640"/>
+            <a:ext cx="10698480" cy="365760"/>
+          </a:xfrm>
+          <a:prstGeom prst="rect">
+            <a:avLst/>
+          </a:prstGeom>
+          <a:noFill/>
+        </p:spPr>
+        <p:txBody>
+          <a:bodyPr wrap="square">
+            <a:spAutoFit/>
+          </a:bodyPr>
+          <a:lstStyle/>
+          <a:p>
+            <a:pPr algn="l"/>
+            <a:r>
+              <a:rPr sz="1000" b="0">
                 <a:solidFill>
                   <a:srgbClr val="A1A1AA"/>
                 </a:solidFill>
-              </a:defRPr>
-            </a:pPr>
-            <a:r>
-              <a:t>academy.kspl.tech | Koenig AI Academy · 06</a:t>
+              </a:rPr>
+              <a:t>academy.kspl.tech | Koenig AI Academy</a:t>
             </a:r>
           </a:p>
         </p:txBody>
@@ -4999,57 +4597,14 @@
       <p:grpSpPr/>
       <p:sp>
         <p:nvSpPr>
-          <p:cNvPr id="2" name="Rectangle 1"/>
-          <p:cNvSpPr/>
-          <p:nvPr/>
-        </p:nvSpPr>
-        <p:spPr>
-          <a:xfrm>
-            <a:off x="0" y="0"/>
-            <a:ext cx="109728" cy="6858000"/>
-          </a:xfrm>
-          <a:prstGeom prst="rect">
-            <a:avLst/>
-          </a:prstGeom>
-          <a:solidFill>
-            <a:srgbClr val="FBBF24"/>
-          </a:solidFill>
-          <a:ln>
-            <a:noFill/>
-          </a:ln>
-        </p:spPr>
-        <p:style>
-          <a:lnRef idx="1">
-            <a:schemeClr val="accent1"/>
-          </a:lnRef>
-          <a:fillRef idx="3">
-            <a:schemeClr val="accent1"/>
-          </a:fillRef>
-          <a:effectRef idx="2">
-            <a:schemeClr val="accent1"/>
-          </a:effectRef>
-          <a:fontRef idx="minor">
-            <a:schemeClr val="lt1"/>
-          </a:fontRef>
-        </p:style>
-        <p:txBody>
-          <a:bodyPr rtlCol="0" anchor="ctr"/>
-          <a:lstStyle/>
-          <a:p>
-            <a:pPr algn="ctr"/>
-          </a:p>
-        </p:txBody>
-      </p:sp>
-      <p:sp>
-        <p:nvSpPr>
-          <p:cNvPr id="3" name="TextBox 2"/>
+          <p:cNvPr id="2" name="TextBox 1"/>
           <p:cNvSpPr txBox="1"/>
           <p:nvPr/>
         </p:nvSpPr>
         <p:spPr>
           <a:xfrm>
-            <a:off x="594360" y="438912"/>
-            <a:ext cx="10881360" cy="1005840"/>
+            <a:off x="914400" y="2011680"/>
+            <a:ext cx="10332720" cy="914400"/>
           </a:xfrm>
           <a:prstGeom prst="rect">
             <a:avLst/>
@@ -5057,34 +4612,33 @@
           <a:noFill/>
         </p:spPr>
         <p:txBody>
-          <a:bodyPr wrap="none">
+          <a:bodyPr wrap="square">
             <a:spAutoFit/>
           </a:bodyPr>
           <a:lstStyle/>
           <a:p>
-            <a:pPr algn="l">
-              <a:defRPr sz="3000" b="1">
+            <a:pPr algn="ctr"/>
+            <a:r>
+              <a:rPr sz="3000" b="1">
                 <a:solidFill>
                   <a:srgbClr val="FFFFFF"/>
                 </a:solidFill>
-              </a:defRPr>
-            </a:pPr>
-            <a:r>
-              <a:t>Pillar 4: Optimize</a:t>
-            </a:r>
-          </a:p>
-        </p:txBody>
-      </p:sp>
-      <p:sp>
-        <p:nvSpPr>
-          <p:cNvPr id="4" name="TextBox 3"/>
+              </a:rPr>
+              <a:t>Read the full article</a:t>
+            </a:r>
+          </a:p>
+        </p:txBody>
+      </p:sp>
+      <p:sp>
+        <p:nvSpPr>
+          <p:cNvPr id="3" name="TextBox 2"/>
           <p:cNvSpPr txBox="1"/>
           <p:nvPr/>
         </p:nvSpPr>
         <p:spPr>
           <a:xfrm>
-            <a:off x="621792" y="1353312"/>
-            <a:ext cx="10607040" cy="411480"/>
+            <a:off x="914400" y="3200400"/>
+            <a:ext cx="10332720" cy="822960"/>
           </a:xfrm>
           <a:prstGeom prst="rect">
             <a:avLst/>
@@ -5092,34 +4646,33 @@
           <a:noFill/>
         </p:spPr>
         <p:txBody>
-          <a:bodyPr wrap="none">
+          <a:bodyPr wrap="square">
             <a:spAutoFit/>
           </a:bodyPr>
           <a:lstStyle/>
           <a:p>
-            <a:pPr>
-              <a:defRPr sz="1400">
-                <a:solidFill>
-                  <a:srgbClr val="D4D4D8"/>
-                </a:solidFill>
-              </a:defRPr>
-            </a:pPr>
-            <a:r>
-              <a:t>How teams measure and improve behavior</a:t>
-            </a:r>
-          </a:p>
-        </p:txBody>
-      </p:sp>
-      <p:sp>
-        <p:nvSpPr>
-          <p:cNvPr id="5" name="TextBox 4"/>
+            <a:pPr algn="ctr"/>
+            <a:r>
+              <a:rPr sz="3600" b="1">
+                <a:solidFill>
+                  <a:srgbClr val="A1A1AA"/>
+                </a:solidFill>
+              </a:rPr>
+              <a:t>academy.kspl.tech</a:t>
+            </a:r>
+          </a:p>
+        </p:txBody>
+      </p:sp>
+      <p:sp>
+        <p:nvSpPr>
+          <p:cNvPr id="4" name="TextBox 3"/>
           <p:cNvSpPr txBox="1"/>
           <p:nvPr/>
         </p:nvSpPr>
         <p:spPr>
           <a:xfrm>
-            <a:off x="804672" y="1965960"/>
-            <a:ext cx="10652760" cy="4069080"/>
+            <a:off x="914400" y="6263640"/>
+            <a:ext cx="10332720" cy="365760"/>
           </a:xfrm>
           <a:prstGeom prst="rect">
             <a:avLst/>
@@ -5132,660 +4685,14 @@
           </a:bodyPr>
           <a:lstStyle/>
           <a:p>
-            <a:pPr marL="0">
-              <a:lnSpc>
-                <a:spcPct val="108000"/>
-              </a:lnSpc>
-              <a:spcAft>
-                <a:spcPts val="1100"/>
-              </a:spcAft>
-              <a:defRPr sz="1900">
-                <a:solidFill>
-                  <a:srgbClr val="FFFFFF"/>
-                </a:solidFill>
-                <a:latin typeface="Aptos"/>
-              </a:defRPr>
-            </a:pPr>
-            <a:r>
-              <a:t>Agent Simulation tests agents against synthetic users and virtualized tools before deployment</a:t>
-            </a:r>
-          </a:p>
-          <a:p>
-            <a:pPr marL="0">
-              <a:lnSpc>
-                <a:spcPct val="108000"/>
-              </a:lnSpc>
-              <a:spcAft>
-                <a:spcPts val="1100"/>
-              </a:spcAft>
-              <a:defRPr sz="1900">
-                <a:solidFill>
-                  <a:srgbClr val="D4D4D8"/>
-                </a:solidFill>
-                <a:latin typeface="Aptos"/>
-              </a:defRPr>
-            </a:pPr>
-            <a:r>
-              <a:t>Agent Evaluation continuously scores multi-turn behavior against rubrics</a:t>
-            </a:r>
-          </a:p>
-          <a:p>
-            <a:pPr marL="0">
-              <a:lnSpc>
-                <a:spcPct val="108000"/>
-              </a:lnSpc>
-              <a:spcAft>
-                <a:spcPts val="1100"/>
-              </a:spcAft>
-              <a:defRPr sz="1900">
-                <a:solidFill>
-                  <a:srgbClr val="D4D4D8"/>
-                </a:solidFill>
-                <a:latin typeface="Aptos"/>
-              </a:defRPr>
-            </a:pPr>
-            <a:r>
-              <a:t>Agent Observability traces model calls, tool calls, memory reads, and handoffs step by step</a:t>
-            </a:r>
-          </a:p>
-          <a:p>
-            <a:pPr marL="0">
-              <a:lnSpc>
-                <a:spcPct val="108000"/>
-              </a:lnSpc>
-              <a:spcAft>
-                <a:spcPts val="1100"/>
-              </a:spcAft>
-              <a:defRPr sz="1900">
-                <a:solidFill>
-                  <a:srgbClr val="D4D4D8"/>
-                </a:solidFill>
-                <a:latin typeface="Aptos"/>
-              </a:defRPr>
-            </a:pPr>
-            <a:r>
-              <a:t>Agent Optimizer clusters failures and suggests instruction refinements rather than applying them autonomously</a:t>
-            </a:r>
-          </a:p>
-        </p:txBody>
-      </p:sp>
-      <p:sp>
-        <p:nvSpPr>
-          <p:cNvPr id="6" name="TextBox 5"/>
-          <p:cNvSpPr txBox="1"/>
-          <p:nvPr/>
-        </p:nvSpPr>
-        <p:spPr>
-          <a:xfrm>
-            <a:off x="502920" y="6446520"/>
-            <a:ext cx="11201400" cy="228600"/>
-          </a:xfrm>
-          <a:prstGeom prst="rect">
-            <a:avLst/>
-          </a:prstGeom>
-          <a:noFill/>
-        </p:spPr>
-        <p:txBody>
-          <a:bodyPr wrap="none">
-            <a:spAutoFit/>
-          </a:bodyPr>
-          <a:lstStyle/>
-          <a:p>
-            <a:pPr algn="r">
-              <a:defRPr sz="800">
+            <a:pPr algn="ctr"/>
+            <a:r>
+              <a:rPr sz="1200" b="0">
                 <a:solidFill>
                   <a:srgbClr val="A1A1AA"/>
                 </a:solidFill>
-              </a:defRPr>
-            </a:pPr>
-            <a:r>
-              <a:t>academy.kspl.tech | Koenig AI Academy · 07</a:t>
-            </a:r>
-          </a:p>
-        </p:txBody>
-      </p:sp>
-    </p:spTree>
-  </p:cSld>
-  <p:clrMapOvr>
-    <a:masterClrMapping/>
-  </p:clrMapOvr>
-</p:sld>
-</file>
-
-<file path=ppt/slides/slide8.xml><?xml version="1.0" encoding="utf-8"?>
-<p:sld xmlns:a="http://schemas.openxmlformats.org/drawingml/2006/main" xmlns:p="http://schemas.openxmlformats.org/presentationml/2006/main" xmlns:r="http://schemas.openxmlformats.org/officeDocument/2006/relationships">
-  <p:cSld>
-    <p:bg>
-      <p:bgPr>
-        <a:solidFill>
-          <a:srgbClr val="18181B"/>
-        </a:solidFill>
-        <a:effectLst/>
-      </p:bgPr>
-    </p:bg>
-    <p:spTree>
-      <p:nvGrpSpPr>
-        <p:cNvPr id="1" name=""/>
-        <p:cNvGrpSpPr/>
-        <p:nvPr/>
-      </p:nvGrpSpPr>
-      <p:grpSpPr/>
-      <p:sp>
-        <p:nvSpPr>
-          <p:cNvPr id="2" name="Rectangle 1"/>
-          <p:cNvSpPr/>
-          <p:nvPr/>
-        </p:nvSpPr>
-        <p:spPr>
-          <a:xfrm>
-            <a:off x="0" y="0"/>
-            <a:ext cx="109728" cy="6858000"/>
-          </a:xfrm>
-          <a:prstGeom prst="rect">
-            <a:avLst/>
-          </a:prstGeom>
-          <a:solidFill>
-            <a:srgbClr val="F87171"/>
-          </a:solidFill>
-          <a:ln>
-            <a:noFill/>
-          </a:ln>
-        </p:spPr>
-        <p:style>
-          <a:lnRef idx="1">
-            <a:schemeClr val="accent1"/>
-          </a:lnRef>
-          <a:fillRef idx="3">
-            <a:schemeClr val="accent1"/>
-          </a:fillRef>
-          <a:effectRef idx="2">
-            <a:schemeClr val="accent1"/>
-          </a:effectRef>
-          <a:fontRef idx="minor">
-            <a:schemeClr val="lt1"/>
-          </a:fontRef>
-        </p:style>
-        <p:txBody>
-          <a:bodyPr rtlCol="0" anchor="ctr"/>
-          <a:lstStyle/>
-          <a:p>
-            <a:pPr algn="ctr"/>
-          </a:p>
-        </p:txBody>
-      </p:sp>
-      <p:sp>
-        <p:nvSpPr>
-          <p:cNvPr id="3" name="TextBox 2"/>
-          <p:cNvSpPr txBox="1"/>
-          <p:nvPr/>
-        </p:nvSpPr>
-        <p:spPr>
-          <a:xfrm>
-            <a:off x="594360" y="438912"/>
-            <a:ext cx="10881360" cy="1005840"/>
-          </a:xfrm>
-          <a:prstGeom prst="rect">
-            <a:avLst/>
-          </a:prstGeom>
-          <a:noFill/>
-        </p:spPr>
-        <p:txBody>
-          <a:bodyPr wrap="none">
-            <a:spAutoFit/>
-          </a:bodyPr>
-          <a:lstStyle/>
-          <a:p>
-            <a:pPr algn="l">
-              <a:defRPr sz="3000" b="1">
-                <a:solidFill>
-                  <a:srgbClr val="FFFFFF"/>
-                </a:solidFill>
-              </a:defRPr>
-            </a:pPr>
-            <a:r>
-              <a:t>What GEAP Is Not</a:t>
-            </a:r>
-          </a:p>
-        </p:txBody>
-      </p:sp>
-      <p:sp>
-        <p:nvSpPr>
-          <p:cNvPr id="4" name="TextBox 3"/>
-          <p:cNvSpPr txBox="1"/>
-          <p:nvPr/>
-        </p:nvSpPr>
-        <p:spPr>
-          <a:xfrm>
-            <a:off x="621792" y="1353312"/>
-            <a:ext cx="10607040" cy="411480"/>
-          </a:xfrm>
-          <a:prstGeom prst="rect">
-            <a:avLst/>
-          </a:prstGeom>
-          <a:noFill/>
-        </p:spPr>
-        <p:txBody>
-          <a:bodyPr wrap="none">
-            <a:spAutoFit/>
-          </a:bodyPr>
-          <a:lstStyle/>
-          <a:p>
-            <a:pPr>
-              <a:defRPr sz="1400">
-                <a:solidFill>
-                  <a:srgbClr val="D4D4D8"/>
-                </a:solidFill>
-              </a:defRPr>
-            </a:pPr>
-            <a:r>
-              <a:t>Three boundaries to keep explicit</a:t>
-            </a:r>
-          </a:p>
-        </p:txBody>
-      </p:sp>
-      <p:sp>
-        <p:nvSpPr>
-          <p:cNvPr id="5" name="TextBox 4"/>
-          <p:cNvSpPr txBox="1"/>
-          <p:nvPr/>
-        </p:nvSpPr>
-        <p:spPr>
-          <a:xfrm>
-            <a:off x="804672" y="1965960"/>
-            <a:ext cx="10652760" cy="4069080"/>
-          </a:xfrm>
-          <a:prstGeom prst="rect">
-            <a:avLst/>
-          </a:prstGeom>
-          <a:noFill/>
-        </p:spPr>
-        <p:txBody>
-          <a:bodyPr wrap="square">
-            <a:spAutoFit/>
-          </a:bodyPr>
-          <a:lstStyle/>
-          <a:p>
-            <a:pPr marL="0">
-              <a:lnSpc>
-                <a:spcPct val="108000"/>
-              </a:lnSpc>
-              <a:spcAft>
-                <a:spcPts val="1100"/>
-              </a:spcAft>
-              <a:defRPr sz="1900">
-                <a:solidFill>
-                  <a:srgbClr val="FFFFFF"/>
-                </a:solidFill>
-                <a:latin typeface="Aptos"/>
-              </a:defRPr>
-            </a:pPr>
-            <a:r>
-              <a:t>It is not model-agnostic in practice; the tightest platform integrations are optimized around Gemini</a:t>
-            </a:r>
-          </a:p>
-          <a:p>
-            <a:pPr marL="0">
-              <a:lnSpc>
-                <a:spcPct val="108000"/>
-              </a:lnSpc>
-              <a:spcAft>
-                <a:spcPts val="1100"/>
-              </a:spcAft>
-              <a:defRPr sz="1900">
-                <a:solidFill>
-                  <a:srgbClr val="D4D4D8"/>
-                </a:solidFill>
-                <a:latin typeface="Aptos"/>
-              </a:defRPr>
-            </a:pPr>
-            <a:r>
-              <a:t>It is not open-source beyond ADK; runtime, memory, gateway, and govern features are proprietary GCP services</a:t>
-            </a:r>
-          </a:p>
-          <a:p>
-            <a:pPr marL="0">
-              <a:lnSpc>
-                <a:spcPct val="108000"/>
-              </a:lnSpc>
-              <a:spcAft>
-                <a:spcPts val="1100"/>
-              </a:spcAft>
-              <a:defRPr sz="1900">
-                <a:solidFill>
-                  <a:srgbClr val="D4D4D8"/>
-                </a:solidFill>
-                <a:latin typeface="Aptos"/>
-              </a:defRPr>
-            </a:pPr>
-            <a:r>
-              <a:t>It is not Dialogflow CX rebranded; GEAP agents reason probabilistically instead of following fixed dialogue flows</a:t>
-            </a:r>
-          </a:p>
-          <a:p>
-            <a:pPr marL="0">
-              <a:lnSpc>
-                <a:spcPct val="108000"/>
-              </a:lnSpc>
-              <a:spcAft>
-                <a:spcPts val="1100"/>
-              </a:spcAft>
-              <a:defRPr sz="1900">
-                <a:solidFill>
-                  <a:srgbClr val="D4D4D8"/>
-                </a:solidFill>
-                <a:latin typeface="Aptos"/>
-              </a:defRPr>
-            </a:pPr>
-            <a:r>
-              <a:t>Using runtime, Memory Bank, and Registry together creates meaningful GCP lock-in</a:t>
-            </a:r>
-          </a:p>
-        </p:txBody>
-      </p:sp>
-      <p:sp>
-        <p:nvSpPr>
-          <p:cNvPr id="6" name="TextBox 5"/>
-          <p:cNvSpPr txBox="1"/>
-          <p:nvPr/>
-        </p:nvSpPr>
-        <p:spPr>
-          <a:xfrm>
-            <a:off x="502920" y="6446520"/>
-            <a:ext cx="11201400" cy="228600"/>
-          </a:xfrm>
-          <a:prstGeom prst="rect">
-            <a:avLst/>
-          </a:prstGeom>
-          <a:noFill/>
-        </p:spPr>
-        <p:txBody>
-          <a:bodyPr wrap="none">
-            <a:spAutoFit/>
-          </a:bodyPr>
-          <a:lstStyle/>
-          <a:p>
-            <a:pPr algn="r">
-              <a:defRPr sz="800">
-                <a:solidFill>
-                  <a:srgbClr val="A1A1AA"/>
-                </a:solidFill>
-              </a:defRPr>
-            </a:pPr>
-            <a:r>
-              <a:t>academy.kspl.tech | Koenig AI Academy · 08</a:t>
-            </a:r>
-          </a:p>
-        </p:txBody>
-      </p:sp>
-    </p:spTree>
-  </p:cSld>
-  <p:clrMapOvr>
-    <a:masterClrMapping/>
-  </p:clrMapOvr>
-</p:sld>
-</file>
-
-<file path=ppt/slides/slide9.xml><?xml version="1.0" encoding="utf-8"?>
-<p:sld xmlns:a="http://schemas.openxmlformats.org/drawingml/2006/main" xmlns:p="http://schemas.openxmlformats.org/presentationml/2006/main" xmlns:r="http://schemas.openxmlformats.org/officeDocument/2006/relationships">
-  <p:cSld>
-    <p:bg>
-      <p:bgPr>
-        <a:solidFill>
-          <a:srgbClr val="18181B"/>
-        </a:solidFill>
-        <a:effectLst/>
-      </p:bgPr>
-    </p:bg>
-    <p:spTree>
-      <p:nvGrpSpPr>
-        <p:cNvPr id="1" name=""/>
-        <p:cNvGrpSpPr/>
-        <p:nvPr/>
-      </p:nvGrpSpPr>
-      <p:grpSpPr/>
-      <p:sp>
-        <p:nvSpPr>
-          <p:cNvPr id="2" name="Rectangle 1"/>
-          <p:cNvSpPr/>
-          <p:nvPr/>
-        </p:nvSpPr>
-        <p:spPr>
-          <a:xfrm>
-            <a:off x="0" y="0"/>
-            <a:ext cx="109728" cy="6858000"/>
-          </a:xfrm>
-          <a:prstGeom prst="rect">
-            <a:avLst/>
-          </a:prstGeom>
-          <a:solidFill>
-            <a:srgbClr val="60A5FA"/>
-          </a:solidFill>
-          <a:ln>
-            <a:noFill/>
-          </a:ln>
-        </p:spPr>
-        <p:style>
-          <a:lnRef idx="1">
-            <a:schemeClr val="accent1"/>
-          </a:lnRef>
-          <a:fillRef idx="3">
-            <a:schemeClr val="accent1"/>
-          </a:fillRef>
-          <a:effectRef idx="2">
-            <a:schemeClr val="accent1"/>
-          </a:effectRef>
-          <a:fontRef idx="minor">
-            <a:schemeClr val="lt1"/>
-          </a:fontRef>
-        </p:style>
-        <p:txBody>
-          <a:bodyPr rtlCol="0" anchor="ctr"/>
-          <a:lstStyle/>
-          <a:p>
-            <a:pPr algn="ctr"/>
-          </a:p>
-        </p:txBody>
-      </p:sp>
-      <p:sp>
-        <p:nvSpPr>
-          <p:cNvPr id="3" name="TextBox 2"/>
-          <p:cNvSpPr txBox="1"/>
-          <p:nvPr/>
-        </p:nvSpPr>
-        <p:spPr>
-          <a:xfrm>
-            <a:off x="594360" y="438912"/>
-            <a:ext cx="10881360" cy="1005840"/>
-          </a:xfrm>
-          <a:prstGeom prst="rect">
-            <a:avLst/>
-          </a:prstGeom>
-          <a:noFill/>
-        </p:spPr>
-        <p:txBody>
-          <a:bodyPr wrap="none">
-            <a:spAutoFit/>
-          </a:bodyPr>
-          <a:lstStyle/>
-          <a:p>
-            <a:pPr algn="l">
-              <a:defRPr sz="3000" b="1">
-                <a:solidFill>
-                  <a:srgbClr val="FFFFFF"/>
-                </a:solidFill>
-              </a:defRPr>
-            </a:pPr>
-            <a:r>
-              <a:t>How Components Connect</a:t>
-            </a:r>
-          </a:p>
-        </p:txBody>
-      </p:sp>
-      <p:sp>
-        <p:nvSpPr>
-          <p:cNvPr id="4" name="TextBox 3"/>
-          <p:cNvSpPr txBox="1"/>
-          <p:nvPr/>
-        </p:nvSpPr>
-        <p:spPr>
-          <a:xfrm>
-            <a:off x="621792" y="1353312"/>
-            <a:ext cx="10607040" cy="411480"/>
-          </a:xfrm>
-          <a:prstGeom prst="rect">
-            <a:avLst/>
-          </a:prstGeom>
-          <a:noFill/>
-        </p:spPr>
-        <p:txBody>
-          <a:bodyPr wrap="none">
-            <a:spAutoFit/>
-          </a:bodyPr>
-          <a:lstStyle/>
-          <a:p>
-            <a:pPr>
-              <a:defRPr sz="1400">
-                <a:solidFill>
-                  <a:srgbClr val="D4D4D8"/>
-                </a:solidFill>
-              </a:defRPr>
-            </a:pPr>
-            <a:r>
-              <a:t>Typical customer-support flow</a:t>
-            </a:r>
-          </a:p>
-        </p:txBody>
-      </p:sp>
-      <p:sp>
-        <p:nvSpPr>
-          <p:cNvPr id="5" name="TextBox 4"/>
-          <p:cNvSpPr txBox="1"/>
-          <p:nvPr/>
-        </p:nvSpPr>
-        <p:spPr>
-          <a:xfrm>
-            <a:off x="804672" y="1965960"/>
-            <a:ext cx="10652760" cy="4069080"/>
-          </a:xfrm>
-          <a:prstGeom prst="rect">
-            <a:avLst/>
-          </a:prstGeom>
-          <a:noFill/>
-        </p:spPr>
-        <p:txBody>
-          <a:bodyPr wrap="square">
-            <a:spAutoFit/>
-          </a:bodyPr>
-          <a:lstStyle/>
-          <a:p>
-            <a:pPr marL="0">
-              <a:lnSpc>
-                <a:spcPct val="108000"/>
-              </a:lnSpc>
-              <a:spcAft>
-                <a:spcPts val="1100"/>
-              </a:spcAft>
-              <a:defRPr sz="1900">
-                <a:solidFill>
-                  <a:srgbClr val="FFFFFF"/>
-                </a:solidFill>
-                <a:latin typeface="Aptos"/>
-              </a:defRPr>
-            </a:pPr>
-            <a:r>
-              <a:t>User request enters through Agent Gateway with Model Armor filtering</a:t>
-            </a:r>
-          </a:p>
-          <a:p>
-            <a:pPr marL="0">
-              <a:lnSpc>
-                <a:spcPct val="108000"/>
-              </a:lnSpc>
-              <a:spcAft>
-                <a:spcPts val="1100"/>
-              </a:spcAft>
-              <a:defRPr sz="1900">
-                <a:solidFill>
-                  <a:srgbClr val="D4D4D8"/>
-                </a:solidFill>
-                <a:latin typeface="Aptos"/>
-              </a:defRPr>
-            </a:pPr>
-            <a:r>
-              <a:t>Agent Runtime resolves Agent Identity, then loads Memory Bank and Session context</a:t>
-            </a:r>
-          </a:p>
-          <a:p>
-            <a:pPr marL="0">
-              <a:lnSpc>
-                <a:spcPct val="108000"/>
-              </a:lnSpc>
-              <a:spcAft>
-                <a:spcPts val="1100"/>
-              </a:spcAft>
-              <a:defRPr sz="1900">
-                <a:solidFill>
-                  <a:srgbClr val="D4D4D8"/>
-                </a:solidFill>
-                <a:latin typeface="Aptos"/>
-              </a:defRPr>
-            </a:pPr>
-            <a:r>
-              <a:t>The ADK agent calls approved tools through Agent Registry</a:t>
-            </a:r>
-          </a:p>
-          <a:p>
-            <a:pPr marL="0">
-              <a:lnSpc>
-                <a:spcPct val="108000"/>
-              </a:lnSpc>
-              <a:spcAft>
-                <a:spcPts val="1100"/>
-              </a:spcAft>
-              <a:defRPr sz="1900">
-                <a:solidFill>
-                  <a:srgbClr val="D4D4D8"/>
-                </a:solidFill>
-                <a:latin typeface="Aptos"/>
-              </a:defRPr>
-            </a:pPr>
-            <a:r>
-              <a:t>Observability records each step, Evaluation scores the response, and Optimizer clusters failures</a:t>
-            </a:r>
-          </a:p>
-        </p:txBody>
-      </p:sp>
-      <p:sp>
-        <p:nvSpPr>
-          <p:cNvPr id="6" name="TextBox 5"/>
-          <p:cNvSpPr txBox="1"/>
-          <p:nvPr/>
-        </p:nvSpPr>
-        <p:spPr>
-          <a:xfrm>
-            <a:off x="502920" y="6446520"/>
-            <a:ext cx="11201400" cy="228600"/>
-          </a:xfrm>
-          <a:prstGeom prst="rect">
-            <a:avLst/>
-          </a:prstGeom>
-          <a:noFill/>
-        </p:spPr>
-        <p:txBody>
-          <a:bodyPr wrap="none">
-            <a:spAutoFit/>
-          </a:bodyPr>
-          <a:lstStyle/>
-          <a:p>
-            <a:pPr algn="r">
-              <a:defRPr sz="800">
-                <a:solidFill>
-                  <a:srgbClr val="A1A1AA"/>
-                </a:solidFill>
-              </a:defRPr>
-            </a:pPr>
-            <a:r>
-              <a:t>academy.kspl.tech | Koenig AI Academy · 09</a:t>
+              </a:rPr>
+              <a:t>Koenig AI Academy</a:t>
             </a:r>
           </a:p>
         </p:txBody>

</xml_diff>

<commit_message>
auto: vault-sync 2026-05-26T11:52:41Z (7 files)
</commit_message>
<xml_diff>
--- a/vault/courses/gemini-enterprise-agents/ch01-slides.pptx
+++ b/vault/courses/gemini-enterprise-agents/ch01-slides.pptx
@@ -3144,40 +3144,6 @@
         </p:nvSpPr>
         <p:spPr>
           <a:xfrm>
-            <a:off x="914400" y="4297680"/>
-            <a:ext cx="10332720" cy="457200"/>
-          </a:xfrm>
-          <a:prstGeom prst="rect">
-            <a:avLst/>
-          </a:prstGeom>
-          <a:noFill/>
-        </p:spPr>
-        <p:txBody>
-          <a:bodyPr wrap="square">
-            <a:spAutoFit/>
-          </a:bodyPr>
-          <a:lstStyle/>
-          <a:p>
-            <a:pPr algn="ctr"/>
-            <a:r>
-              <a:rPr sz="1600" b="0">
-                <a:solidFill>
-                  <a:srgbClr val="A1A1AA"/>
-                </a:solidFill>
-              </a:rPr>
-              <a:t>2026-04-30</a:t>
-            </a:r>
-          </a:p>
-        </p:txBody>
-      </p:sp>
-      <p:sp>
-        <p:nvSpPr>
-          <p:cNvPr id="4" name="TextBox 3"/>
-          <p:cNvSpPr txBox="1"/>
-          <p:nvPr/>
-        </p:nvSpPr>
-        <p:spPr>
-          <a:xfrm>
             <a:off x="731520" y="6263640"/>
             <a:ext cx="10698480" cy="365760"/>
           </a:xfrm>
@@ -3438,7 +3404,7 @@
                   <a:srgbClr val="FFFFFF"/>
                 </a:solidFill>
               </a:rPr>
-              <a:t>  Model access: 200+ models including Gemini 3.1 Pro/Flash, Gemma 4, Anthropic Claude (Opus/Sonnet/Haiku), and third-party</a:t>
+              <a:t>  Model access: 200+ models including Gemini 3.1 Pro/Flash, Gemma 4, Anthropic Claude (Opus/Sonnet/Haiku), and third-party open models</a:t>
             </a:r>
           </a:p>
         </p:txBody>
@@ -3609,7 +3575,7 @@
                   <a:srgbClr val="FFFFFF"/>
                 </a:solidFill>
               </a:rPr>
-              <a:t>  When Google announced GEAP, industry coverage focused on the new features: sub-agent networks, Memory Bank, Agent Identi</a:t>
+              <a:t>  When Google announced GEAP, industry coverage focused on the new features: sub-agent networks, Memory Bank, Agent Identity. The buried lede </a:t>
             </a:r>
           </a:p>
         </p:txBody>
@@ -3643,7 +3609,7 @@
                   <a:srgbClr val="FFFFFF"/>
                 </a:solidFill>
               </a:rPr>
-              <a:t>  That is a major commitment. It means if you are using Vertex AI Pipelines, Vertex AI Evaluation, or any other standalone</a:t>
+              <a:t>  That is a major commitment. It means if you are using Vertex AI Pipelines, Vertex AI Evaluation, or any other standalone Vertex service, you</a:t>
             </a:r>
           </a:p>
         </p:txBody>
@@ -3677,7 +3643,7 @@
                   <a:srgbClr val="FFFFFF"/>
                 </a:solidFill>
               </a:rPr>
-              <a:t>  Model Surfaces vs. Agent Platform: Google's frontier models (like Gemini 3.1 Pro) appear in multiple "surfaces" simultan</a:t>
+              <a:t>  Model Surfaces vs. Agent Platform: Google's frontier models (like Gemini 3.1 Pro) appear in multiple "surfaces" simultaneously. You might se</a:t>
             </a:r>
           </a:p>
         </p:txBody>
@@ -3711,7 +3677,7 @@
                   <a:srgbClr val="FFFFFF"/>
                 </a:solidFill>
               </a:rPr>
-              <a:t>  Whether that bet pays off for you depends on your use case. This chapter explains the architecture so you can make that </a:t>
+              <a:t>  Whether that bet pays off for you depends on your use case. This chapter explains the architecture so you can make that judgment with clear </a:t>
             </a:r>
           </a:p>
         </p:txBody>
@@ -3882,7 +3848,7 @@
                   <a:srgbClr val="FFFFFF"/>
                 </a:solidFill>
               </a:rPr>
-              <a:t>  GEAP is organized into four operational domains. Every feature belongs to one of them. Knowing which pillar a feature be</a:t>
+              <a:t>  GEAP is organized into four operational domains. Every feature belongs to one of them. Knowing which pillar a feature belongs to tells you w</a:t>
             </a:r>
           </a:p>
         </p:txBody>
@@ -3984,7 +3950,7 @@
                   <a:srgbClr val="FFFFFF"/>
                 </a:solidFill>
               </a:rPr>
-              <a:t>  Agent Studio is a low-code, visual interface. You drag components, define tools from a catalogue, set an instruction pro</a:t>
+              <a:t>  Agent Studio is a low-code, visual interface. You drag components, define tools from a catalogue, set an instruction prompt, and get a deplo</a:t>
             </a:r>
           </a:p>
         </p:txBody>
@@ -4189,7 +4155,7 @@
                   <a:srgbClr val="FFFFFF"/>
                 </a:solidFill>
               </a:rPr>
-              <a:t>  It is not model-agnostic in practice. GEAP supports 200+ models including Claude and open models. But the tightest integ</a:t>
+              <a:t>  It is not model-agnostic in practice. GEAP supports 200+ models including Claude and open models. But the tightest integrations — Memory Ban</a:t>
             </a:r>
           </a:p>
         </p:txBody>
@@ -4223,7 +4189,7 @@
                   <a:srgbClr val="FFFFFF"/>
                 </a:solidFill>
               </a:rPr>
-              <a:t>  It is not open-source. The ADK is open-source (Apache 2.0). The runtime, Memory Bank, Agent Gateway, and Govern features</a:t>
+              <a:t>  It is not open-source. The ADK is open-source (Apache 2.0). The runtime, Memory Bank, Agent Gateway, and Govern features are fully proprieta</a:t>
             </a:r>
           </a:p>
         </p:txBody>
@@ -4257,7 +4223,7 @@
                   <a:srgbClr val="FFFFFF"/>
                 </a:solidFill>
               </a:rPr>
-              <a:t>  It is not Dialogflow CX rebranded. Dialogflow CX was a flow-based, deterministic dialogue manager. GEAP's agents reason </a:t>
+              <a:t>  It is not Dialogflow CX rebranded. Dialogflow CX was a flow-based, deterministic dialogue manager. GEAP's agents reason with LLMs and make p</a:t>
             </a:r>
           </a:p>
         </p:txBody>
@@ -4619,12 +4585,12 @@
           <a:p>
             <a:pPr algn="ctr"/>
             <a:r>
-              <a:rPr sz="3000" b="1">
+              <a:rPr sz="3400" b="1">
                 <a:solidFill>
                   <a:srgbClr val="FFFFFF"/>
                 </a:solidFill>
               </a:rPr>
-              <a:t>Read the full article</a:t>
+              <a:t>Try it next</a:t>
             </a:r>
           </a:p>
         </p:txBody>
@@ -4638,7 +4604,7 @@
         <p:spPr>
           <a:xfrm>
             <a:off x="914400" y="3200400"/>
-            <a:ext cx="10332720" cy="822960"/>
+            <a:ext cx="10332720" cy="1097280"/>
           </a:xfrm>
           <a:prstGeom prst="rect">
             <a:avLst/>
@@ -4653,12 +4619,12 @@
           <a:p>
             <a:pPr algn="ctr"/>
             <a:r>
-              <a:rPr sz="3600" b="1">
+              <a:rPr sz="2000" b="0">
                 <a:solidFill>
                   <a:srgbClr val="A1A1AA"/>
                 </a:solidFill>
               </a:rPr>
-              <a:t>academy.kspl.tech</a:t>
+              <a:t>Deploy a gateway with RBAC, rate limits, and JSONL auditing</a:t>
             </a:r>
           </a:p>
         </p:txBody>
@@ -4671,8 +4637,8 @@
         </p:nvSpPr>
         <p:spPr>
           <a:xfrm>
-            <a:off x="914400" y="6263640"/>
-            <a:ext cx="10332720" cy="365760"/>
+            <a:off x="731520" y="6263640"/>
+            <a:ext cx="10698480" cy="365760"/>
           </a:xfrm>
           <a:prstGeom prst="rect">
             <a:avLst/>
@@ -4685,14 +4651,14 @@
           </a:bodyPr>
           <a:lstStyle/>
           <a:p>
-            <a:pPr algn="ctr"/>
-            <a:r>
-              <a:rPr sz="1200" b="0">
+            <a:pPr algn="l"/>
+            <a:r>
+              <a:rPr sz="1000" b="0">
                 <a:solidFill>
                   <a:srgbClr val="A1A1AA"/>
                 </a:solidFill>
               </a:rPr>
-              <a:t>Koenig AI Academy</a:t>
+              <a:t>academy.kspl.tech | Koenig AI Academy</a:t>
             </a:r>
           </a:p>
         </p:txBody>

</xml_diff>